<commit_message>
feat(media): implement Track 4 - demo video clips, printable test cards, failsafe recording, demo script, and PPTX alignment
</commit_message>
<xml_diff>
--- a/SIH26_TEAM_VIGILANCE.pptx
+++ b/SIH26_TEAM_VIGILANCE.pptx
@@ -5563,6 +5563,10 @@
             <a:prstDash val="solid"/>
           </a:ln>
         </p:spPr>
+        <p:txBody>
+          <a:bodyPr/>
+          <a:p/>
+        </p:txBody>
       </p:sp>
       <p:sp>
         <p:nvSpPr>
@@ -5588,6 +5592,10 @@
             <a:prstDash val="solid"/>
           </a:ln>
         </p:spPr>
+        <p:txBody>
+          <a:bodyPr/>
+          <a:p/>
+        </p:txBody>
       </p:sp>
       <p:pic>
         <p:nvPicPr>
@@ -5693,6 +5701,10 @@
             <a:prstDash val="solid"/>
           </a:ln>
         </p:spPr>
+        <p:txBody>
+          <a:bodyPr/>
+          <a:p/>
+        </p:txBody>
       </p:sp>
       <p:pic>
         <p:nvPicPr>
@@ -5792,6 +5804,10 @@
             <a:prstDash val="solid"/>
           </a:ln>
         </p:spPr>
+        <p:txBody>
+          <a:bodyPr/>
+          <a:p/>
+        </p:txBody>
       </p:sp>
       <p:pic>
         <p:nvPicPr>
@@ -5891,6 +5907,10 @@
             <a:prstDash val="solid"/>
           </a:ln>
         </p:spPr>
+        <p:txBody>
+          <a:bodyPr/>
+          <a:p/>
+        </p:txBody>
       </p:sp>
       <p:pic>
         <p:nvPicPr>
@@ -5990,6 +6010,10 @@
             <a:prstDash val="solid"/>
           </a:ln>
         </p:spPr>
+        <p:txBody>
+          <a:bodyPr/>
+          <a:p/>
+        </p:txBody>
       </p:sp>
       <p:pic>
         <p:nvPicPr>
@@ -6091,6 +6115,10 @@
             <a:prstDash val="solid"/>
           </a:ln>
         </p:spPr>
+        <p:txBody>
+          <a:bodyPr/>
+          <a:p/>
+        </p:txBody>
       </p:sp>
       <p:pic>
         <p:nvPicPr>
@@ -6192,6 +6220,10 @@
             <a:prstDash val="solid"/>
           </a:ln>
         </p:spPr>
+        <p:txBody>
+          <a:bodyPr/>
+          <a:p/>
+        </p:txBody>
       </p:sp>
       <p:sp>
         <p:nvSpPr>
@@ -6214,6 +6246,10 @@
           </a:solidFill>
           <a:ln/>
         </p:spPr>
+        <p:txBody>
+          <a:bodyPr/>
+          <a:p/>
+        </p:txBody>
       </p:sp>
       <p:sp>
         <p:nvSpPr>
@@ -6280,6 +6316,10 @@
             <a:prstDash val="solid"/>
           </a:ln>
         </p:spPr>
+        <p:txBody>
+          <a:bodyPr/>
+          <a:p/>
+        </p:txBody>
       </p:sp>
       <p:sp>
         <p:nvSpPr>
@@ -6307,6 +6347,10 @@
             <a:prstDash val="solid"/>
           </a:ln>
         </p:spPr>
+        <p:txBody>
+          <a:bodyPr/>
+          <a:p/>
+        </p:txBody>
       </p:sp>
       <p:sp>
         <p:nvSpPr>
@@ -6334,6 +6378,10 @@
             <a:prstDash val="solid"/>
           </a:ln>
         </p:spPr>
+        <p:txBody>
+          <a:bodyPr/>
+          <a:p/>
+        </p:txBody>
       </p:sp>
       <p:sp>
         <p:nvSpPr>
@@ -6361,6 +6409,10 @@
             <a:prstDash val="solid"/>
           </a:ln>
         </p:spPr>
+        <p:txBody>
+          <a:bodyPr/>
+          <a:p/>
+        </p:txBody>
       </p:sp>
       <p:sp>
         <p:nvSpPr>
@@ -6388,6 +6440,10 @@
             <a:prstDash val="solid"/>
           </a:ln>
         </p:spPr>
+        <p:txBody>
+          <a:bodyPr/>
+          <a:p/>
+        </p:txBody>
       </p:sp>
       <p:sp>
         <p:nvSpPr>
@@ -7382,6 +7438,10 @@
           </a:solidFill>
           <a:ln/>
         </p:spPr>
+        <p:txBody>
+          <a:bodyPr/>
+          <a:p/>
+        </p:txBody>
       </p:sp>
       <p:sp>
         <p:nvSpPr>
@@ -7402,6 +7462,10 @@
           </a:solidFill>
           <a:ln/>
         </p:spPr>
+        <p:txBody>
+          <a:bodyPr/>
+          <a:p/>
+        </p:txBody>
       </p:sp>
       <p:sp>
         <p:nvSpPr>
@@ -7422,6 +7486,10 @@
           </a:solidFill>
           <a:ln/>
         </p:spPr>
+        <p:txBody>
+          <a:bodyPr/>
+          <a:p/>
+        </p:txBody>
       </p:sp>
       <p:sp>
         <p:nvSpPr>
@@ -7442,6 +7510,10 @@
           </a:solidFill>
           <a:ln/>
         </p:spPr>
+        <p:txBody>
+          <a:bodyPr/>
+          <a:p/>
+        </p:txBody>
       </p:sp>
       <p:sp>
         <p:nvSpPr>
@@ -7469,6 +7541,10 @@
             <a:prstDash val="solid"/>
           </a:ln>
         </p:spPr>
+        <p:txBody>
+          <a:bodyPr/>
+          <a:p/>
+        </p:txBody>
       </p:sp>
       <p:sp>
         <p:nvSpPr>
@@ -7491,6 +7567,10 @@
           </a:solidFill>
           <a:ln/>
         </p:spPr>
+        <p:txBody>
+          <a:bodyPr/>
+          <a:p/>
+        </p:txBody>
       </p:sp>
       <p:sp>
         <p:nvSpPr>
@@ -7557,6 +7637,10 @@
             <a:prstDash val="solid"/>
           </a:ln>
         </p:spPr>
+        <p:txBody>
+          <a:bodyPr/>
+          <a:p/>
+        </p:txBody>
       </p:sp>
       <p:sp>
         <p:nvSpPr>
@@ -7584,6 +7668,10 @@
             <a:prstDash val="solid"/>
           </a:ln>
         </p:spPr>
+        <p:txBody>
+          <a:bodyPr/>
+          <a:p/>
+        </p:txBody>
       </p:sp>
       <p:sp>
         <p:nvSpPr>
@@ -7611,6 +7699,10 @@
             <a:prstDash val="solid"/>
           </a:ln>
         </p:spPr>
+        <p:txBody>
+          <a:bodyPr/>
+          <a:p/>
+        </p:txBody>
       </p:sp>
       <p:sp>
         <p:nvSpPr>
@@ -7638,6 +7730,10 @@
             <a:prstDash val="solid"/>
           </a:ln>
         </p:spPr>
+        <p:txBody>
+          <a:bodyPr/>
+          <a:p/>
+        </p:txBody>
       </p:sp>
       <p:sp>
         <p:nvSpPr>
@@ -7665,6 +7761,10 @@
             <a:prstDash val="solid"/>
           </a:ln>
         </p:spPr>
+        <p:txBody>
+          <a:bodyPr/>
+          <a:p/>
+        </p:txBody>
       </p:sp>
       <p:sp>
         <p:nvSpPr>
@@ -8420,6 +8520,10 @@
           </a:solidFill>
           <a:ln/>
         </p:spPr>
+        <p:txBody>
+          <a:bodyPr/>
+          <a:p/>
+        </p:txBody>
       </p:sp>
       <p:sp>
         <p:nvSpPr>
@@ -8440,6 +8544,10 @@
           </a:solidFill>
           <a:ln/>
         </p:spPr>
+        <p:txBody>
+          <a:bodyPr/>
+          <a:p/>
+        </p:txBody>
       </p:sp>
       <p:sp>
         <p:nvSpPr>
@@ -8460,6 +8568,10 @@
           </a:solidFill>
           <a:ln/>
         </p:spPr>
+        <p:txBody>
+          <a:bodyPr/>
+          <a:p/>
+        </p:txBody>
       </p:sp>
       <p:sp>
         <p:nvSpPr>
@@ -8480,6 +8592,10 @@
           </a:solidFill>
           <a:ln/>
         </p:spPr>
+        <p:txBody>
+          <a:bodyPr/>
+          <a:p/>
+        </p:txBody>
       </p:sp>
       <p:sp>
         <p:nvSpPr>
@@ -8507,6 +8623,10 @@
             <a:prstDash val="solid"/>
           </a:ln>
         </p:spPr>
+        <p:txBody>
+          <a:bodyPr/>
+          <a:p/>
+        </p:txBody>
       </p:sp>
       <p:pic>
         <p:nvPicPr>
@@ -8930,6 +9050,10 @@
             <a:prstDash val="solid"/>
           </a:ln>
         </p:spPr>
+        <p:txBody>
+          <a:bodyPr/>
+          <a:p/>
+        </p:txBody>
       </p:sp>
       <p:sp>
         <p:nvSpPr>
@@ -8953,6 +9077,10 @@
             <a:prstDash val="solid"/>
           </a:ln>
         </p:spPr>
+        <p:txBody>
+          <a:bodyPr/>
+          <a:p/>
+        </p:txBody>
       </p:sp>
       <p:sp>
         <p:nvSpPr>
@@ -8976,6 +9104,10 @@
             <a:prstDash val="solid"/>
           </a:ln>
         </p:spPr>
+        <p:txBody>
+          <a:bodyPr/>
+          <a:p/>
+        </p:txBody>
       </p:sp>
       <p:sp>
         <p:nvSpPr>
@@ -8999,6 +9131,10 @@
             <a:prstDash val="solid"/>
           </a:ln>
         </p:spPr>
+        <p:txBody>
+          <a:bodyPr/>
+          <a:p/>
+        </p:txBody>
       </p:sp>
       <p:sp>
         <p:nvSpPr>
@@ -9019,6 +9155,10 @@
           </a:solidFill>
           <a:ln/>
         </p:spPr>
+        <p:txBody>
+          <a:bodyPr/>
+          <a:p/>
+        </p:txBody>
       </p:sp>
       <p:sp>
         <p:nvSpPr>
@@ -9257,6 +9397,10 @@
             <a:prstDash val="solid"/>
           </a:ln>
         </p:spPr>
+        <p:txBody>
+          <a:bodyPr/>
+          <a:p/>
+        </p:txBody>
       </p:sp>
       <p:sp>
         <p:nvSpPr>
@@ -9279,6 +9423,10 @@
           </a:solidFill>
           <a:ln/>
         </p:spPr>
+        <p:txBody>
+          <a:bodyPr/>
+          <a:p/>
+        </p:txBody>
       </p:sp>
       <p:sp>
         <p:nvSpPr>
@@ -9340,6 +9488,10 @@
           </a:solidFill>
           <a:ln/>
         </p:spPr>
+        <p:txBody>
+          <a:bodyPr/>
+          <a:p/>
+        </p:txBody>
       </p:sp>
       <p:sp>
         <p:nvSpPr>
@@ -9365,6 +9517,10 @@
             <a:prstDash val="solid"/>
           </a:ln>
         </p:spPr>
+        <p:txBody>
+          <a:bodyPr/>
+          <a:p/>
+        </p:txBody>
       </p:sp>
       <p:pic>
         <p:nvPicPr>
@@ -9479,15 +9635,7 @@
               <a:buChar char="•"/>
             </a:pPr>
             <a:r>
-              <a:rPr lang="en-US" sz="1000" dirty="0">
-                <a:solidFill>
-                  <a:srgbClr val="222B3A"/>
-                </a:solidFill>
-                <a:latin typeface="Calibri" pitchFamily="34" charset="0"/>
-                <a:ea typeface="Calibri" pitchFamily="34" charset="-122"/>
-                <a:cs typeface="Calibri" pitchFamily="34" charset="-120"/>
-              </a:rPr>
-              <a:t>YOLOv8-Nano / YOLOv11-Nano</a:t>
+              <a:t>YOLOv8-Nano INT8 ONNX (3.2 MB, 28.4ms, 39.89% mAP@50 on 7,706 RDD2022 images)</a:t>
             </a:r>
             <a:endParaRPr lang="en-US" sz="1000" dirty="0"/>
           </a:p>
@@ -9535,6 +9683,10 @@
           </a:solidFill>
           <a:ln/>
         </p:spPr>
+        <p:txBody>
+          <a:bodyPr/>
+          <a:p/>
+        </p:txBody>
       </p:sp>
       <p:sp>
         <p:nvSpPr>
@@ -9560,6 +9712,10 @@
             <a:prstDash val="solid"/>
           </a:ln>
         </p:spPr>
+        <p:txBody>
+          <a:bodyPr/>
+          <a:p/>
+        </p:txBody>
       </p:sp>
       <p:pic>
         <p:nvPicPr>
@@ -9674,15 +9830,7 @@
               <a:buChar char="•"/>
             </a:pPr>
             <a:r>
-              <a:rPr lang="en-US" sz="1000" dirty="0">
-                <a:solidFill>
-                  <a:srgbClr val="222B3A"/>
-                </a:solidFill>
-                <a:latin typeface="Calibri" pitchFamily="34" charset="0"/>
-                <a:ea typeface="Calibri" pitchFamily="34" charset="-122"/>
-                <a:cs typeface="Calibri" pitchFamily="34" charset="-120"/>
-              </a:rPr>
-              <a:t>PostgreSQL + PostGIS</a:t>
+              <a:t>PostgreSQL 17 + PostGIS 3.3 (ST_ClusterDBSCAN 15m radius)</a:t>
             </a:r>
             <a:endParaRPr lang="en-US" sz="1000" dirty="0"/>
           </a:p>
@@ -9695,15 +9843,7 @@
               <a:buChar char="•"/>
             </a:pPr>
             <a:r>
-              <a:rPr lang="en-US" sz="1000" dirty="0">
-                <a:solidFill>
-                  <a:srgbClr val="222B3A"/>
-                </a:solidFill>
-                <a:latin typeface="Calibri" pitchFamily="34" charset="0"/>
-                <a:ea typeface="Calibri" pitchFamily="34" charset="-122"/>
-                <a:cs typeface="Calibri" pitchFamily="34" charset="-120"/>
-              </a:rPr>
-              <a:t>DBSCAN for spatial deduplication</a:t>
+              <a:t>DBSCAN 15m Deduplication + Dynamic RPI Formula (0.40S+0.25D+0.20R+0.15P)</a:t>
             </a:r>
             <a:endParaRPr lang="en-US" sz="1000" dirty="0"/>
           </a:p>
@@ -9730,6 +9870,10 @@
           </a:solidFill>
           <a:ln/>
         </p:spPr>
+        <p:txBody>
+          <a:bodyPr/>
+          <a:p/>
+        </p:txBody>
       </p:sp>
       <p:sp>
         <p:nvSpPr>
@@ -9755,6 +9899,10 @@
             <a:prstDash val="solid"/>
           </a:ln>
         </p:spPr>
+        <p:txBody>
+          <a:bodyPr/>
+          <a:p/>
+        </p:txBody>
       </p:sp>
       <p:pic>
         <p:nvPicPr>
@@ -9848,15 +9996,7 @@
               <a:buChar char="•"/>
             </a:pPr>
             <a:r>
-              <a:rPr lang="en-US" sz="1000" dirty="0">
-                <a:solidFill>
-                  <a:srgbClr val="222B3A"/>
-                </a:solidFill>
-                <a:latin typeface="Calibri" pitchFamily="34" charset="0"/>
-                <a:ea typeface="Calibri" pitchFamily="34" charset="-122"/>
-                <a:cs typeface="Calibri" pitchFamily="34" charset="-120"/>
-              </a:rPr>
-              <a:t>React / Next.js</a:t>
+              <a:t>Next.js 14 PWA (WebAssembly ONNX + WebAudio Chime + Hardware HUD)</a:t>
             </a:r>
             <a:endParaRPr lang="en-US" sz="1000" dirty="0"/>
           </a:p>
@@ -9925,6 +10065,10 @@
           </a:solidFill>
           <a:ln/>
         </p:spPr>
+        <p:txBody>
+          <a:bodyPr/>
+          <a:p/>
+        </p:txBody>
       </p:sp>
       <p:sp>
         <p:nvSpPr>
@@ -9950,6 +10094,10 @@
             <a:prstDash val="solid"/>
           </a:ln>
         </p:spPr>
+        <p:txBody>
+          <a:bodyPr/>
+          <a:p/>
+        </p:txBody>
       </p:sp>
       <p:pic>
         <p:nvPicPr>
@@ -10064,15 +10212,7 @@
               <a:buChar char="•"/>
             </a:pPr>
             <a:r>
-              <a:rPr lang="en-US" sz="1000" dirty="0">
-                <a:solidFill>
-                  <a:srgbClr val="222B3A"/>
-                </a:solidFill>
-                <a:latin typeface="Calibri" pitchFamily="34" charset="0"/>
-                <a:ea typeface="Calibri" pitchFamily="34" charset="-122"/>
-                <a:cs typeface="Calibri" pitchFamily="34" charset="-120"/>
-              </a:rPr>
-              <a:t>MQTT for lightweight transmission</a:t>
+              <a:t>OASIS MQTT v5 (99.8% bandwidth saved via 200-byte telemetry)</a:t>
             </a:r>
             <a:endParaRPr lang="en-US" sz="1000" dirty="0"/>
           </a:p>
@@ -10120,6 +10260,10 @@
           </a:solidFill>
           <a:ln/>
         </p:spPr>
+        <p:txBody>
+          <a:bodyPr/>
+          <a:p/>
+        </p:txBody>
       </p:sp>
       <p:sp>
         <p:nvSpPr>
@@ -10186,6 +10330,10 @@
             <a:prstDash val="solid"/>
           </a:ln>
         </p:spPr>
+        <p:txBody>
+          <a:bodyPr/>
+          <a:p/>
+        </p:txBody>
       </p:sp>
       <p:sp>
         <p:nvSpPr>
@@ -10208,6 +10356,10 @@
           </a:solidFill>
           <a:ln/>
         </p:spPr>
+        <p:txBody>
+          <a:bodyPr/>
+          <a:p/>
+        </p:txBody>
       </p:sp>
       <p:sp>
         <p:nvSpPr>
@@ -10274,6 +10426,10 @@
             <a:prstDash val="solid"/>
           </a:ln>
         </p:spPr>
+        <p:txBody>
+          <a:bodyPr/>
+          <a:p/>
+        </p:txBody>
       </p:sp>
       <p:sp>
         <p:nvSpPr>
@@ -10402,6 +10558,10 @@
             <a:prstDash val="solid"/>
           </a:ln>
         </p:spPr>
+        <p:txBody>
+          <a:bodyPr/>
+          <a:p/>
+        </p:txBody>
       </p:sp>
       <p:sp>
         <p:nvSpPr>
@@ -10513,6 +10673,10 @@
             <a:prstDash val="solid"/>
           </a:ln>
         </p:spPr>
+        <p:txBody>
+          <a:bodyPr/>
+          <a:p/>
+        </p:txBody>
       </p:sp>
       <p:sp>
         <p:nvSpPr>
@@ -10641,6 +10805,10 @@
             <a:prstDash val="solid"/>
           </a:ln>
         </p:spPr>
+        <p:txBody>
+          <a:bodyPr/>
+          <a:p/>
+        </p:txBody>
       </p:sp>
       <p:sp>
         <p:nvSpPr>
@@ -10769,6 +10937,10 @@
             <a:prstDash val="solid"/>
           </a:ln>
         </p:spPr>
+        <p:txBody>
+          <a:bodyPr/>
+          <a:p/>
+        </p:txBody>
       </p:sp>
       <p:sp>
         <p:nvSpPr>
@@ -10993,6 +11165,10 @@
           </a:solidFill>
           <a:ln/>
         </p:spPr>
+        <p:txBody>
+          <a:bodyPr/>
+          <a:p/>
+        </p:txBody>
       </p:sp>
       <p:sp>
         <p:nvSpPr>
@@ -11052,6 +11228,10 @@
           </a:solidFill>
           <a:ln/>
         </p:spPr>
+        <p:txBody>
+          <a:bodyPr/>
+          <a:p/>
+        </p:txBody>
       </p:sp>
       <p:sp>
         <p:nvSpPr>
@@ -11111,6 +11291,10 @@
           </a:solidFill>
           <a:ln/>
         </p:spPr>
+        <p:txBody>
+          <a:bodyPr/>
+          <a:p/>
+        </p:txBody>
       </p:sp>
       <p:sp>
         <p:nvSpPr>
@@ -11170,6 +11354,10 @@
           </a:solidFill>
           <a:ln/>
         </p:spPr>
+        <p:txBody>
+          <a:bodyPr/>
+          <a:p/>
+        </p:txBody>
       </p:sp>
       <p:sp>
         <p:nvSpPr>
@@ -11612,6 +11800,10 @@
           </a:solidFill>
           <a:ln/>
         </p:spPr>
+        <p:txBody>
+          <a:bodyPr/>
+          <a:p/>
+        </p:txBody>
       </p:sp>
       <p:sp>
         <p:nvSpPr>
@@ -11632,6 +11824,10 @@
           </a:solidFill>
           <a:ln/>
         </p:spPr>
+        <p:txBody>
+          <a:bodyPr/>
+          <a:p/>
+        </p:txBody>
       </p:sp>
       <p:sp>
         <p:nvSpPr>
@@ -11652,6 +11848,10 @@
           </a:solidFill>
           <a:ln/>
         </p:spPr>
+        <p:txBody>
+          <a:bodyPr/>
+          <a:p/>
+        </p:txBody>
       </p:sp>
       <p:sp>
         <p:nvSpPr>
@@ -11672,6 +11872,10 @@
           </a:solidFill>
           <a:ln/>
         </p:spPr>
+        <p:txBody>
+          <a:bodyPr/>
+          <a:p/>
+        </p:txBody>
       </p:sp>
       <p:sp>
         <p:nvSpPr>
@@ -11692,6 +11896,10 @@
           </a:solidFill>
           <a:ln/>
         </p:spPr>
+        <p:txBody>
+          <a:bodyPr/>
+          <a:p/>
+        </p:txBody>
       </p:sp>
       <p:sp>
         <p:nvSpPr>
@@ -11719,6 +11927,10 @@
             <a:prstDash val="solid"/>
           </a:ln>
         </p:spPr>
+        <p:txBody>
+          <a:bodyPr/>
+          <a:p/>
+        </p:txBody>
       </p:sp>
       <p:sp>
         <p:nvSpPr>
@@ -11741,6 +11953,10 @@
           </a:solidFill>
           <a:ln/>
         </p:spPr>
+        <p:txBody>
+          <a:bodyPr/>
+          <a:p/>
+        </p:txBody>
       </p:sp>
       <p:sp>
         <p:nvSpPr>
@@ -11807,6 +12023,10 @@
             <a:prstDash val="solid"/>
           </a:ln>
         </p:spPr>
+        <p:txBody>
+          <a:bodyPr/>
+          <a:p/>
+        </p:txBody>
       </p:sp>
       <p:sp>
         <p:nvSpPr>
@@ -11918,6 +12138,10 @@
             <a:prstDash val="solid"/>
           </a:ln>
         </p:spPr>
+        <p:txBody>
+          <a:bodyPr/>
+          <a:p/>
+        </p:txBody>
       </p:sp>
       <p:sp>
         <p:nvSpPr>
@@ -12029,6 +12253,10 @@
             <a:prstDash val="solid"/>
           </a:ln>
         </p:spPr>
+        <p:txBody>
+          <a:bodyPr/>
+          <a:p/>
+        </p:txBody>
       </p:sp>
       <p:sp>
         <p:nvSpPr>
@@ -12140,6 +12368,10 @@
             <a:prstDash val="solid"/>
           </a:ln>
         </p:spPr>
+        <p:txBody>
+          <a:bodyPr/>
+          <a:p/>
+        </p:txBody>
       </p:sp>
       <p:sp>
         <p:nvSpPr>
@@ -12251,6 +12483,10 @@
             <a:prstDash val="solid"/>
           </a:ln>
         </p:spPr>
+        <p:txBody>
+          <a:bodyPr/>
+          <a:p/>
+        </p:txBody>
       </p:sp>
       <p:sp>
         <p:nvSpPr>
@@ -12670,6 +12906,10 @@
           </a:solidFill>
           <a:ln/>
         </p:spPr>
+        <p:txBody>
+          <a:bodyPr/>
+          <a:p/>
+        </p:txBody>
       </p:sp>
       <p:sp>
         <p:nvSpPr>
@@ -12690,6 +12930,10 @@
           </a:solidFill>
           <a:ln/>
         </p:spPr>
+        <p:txBody>
+          <a:bodyPr/>
+          <a:p/>
+        </p:txBody>
       </p:sp>
       <p:sp>
         <p:nvSpPr>
@@ -12710,6 +12954,10 @@
           </a:solidFill>
           <a:ln/>
         </p:spPr>
+        <p:txBody>
+          <a:bodyPr/>
+          <a:p/>
+        </p:txBody>
       </p:sp>
       <p:sp>
         <p:nvSpPr>
@@ -12730,6 +12978,10 @@
           </a:solidFill>
           <a:ln/>
         </p:spPr>
+        <p:txBody>
+          <a:bodyPr/>
+          <a:p/>
+        </p:txBody>
       </p:sp>
       <p:sp>
         <p:nvSpPr>
@@ -12757,6 +13009,10 @@
             <a:prstDash val="solid"/>
           </a:ln>
         </p:spPr>
+        <p:txBody>
+          <a:bodyPr/>
+          <a:p/>
+        </p:txBody>
       </p:sp>
       <p:pic>
         <p:nvPicPr>
@@ -12862,6 +13118,10 @@
             <a:prstDash val="solid"/>
           </a:ln>
         </p:spPr>
+        <p:txBody>
+          <a:bodyPr/>
+          <a:p/>
+        </p:txBody>
       </p:sp>
       <p:pic>
         <p:nvPicPr>
@@ -12950,6 +13210,10 @@
             <a:prstDash val="solid"/>
           </a:ln>
         </p:spPr>
+        <p:txBody>
+          <a:bodyPr/>
+          <a:p/>
+        </p:txBody>
       </p:sp>
       <p:pic>
         <p:nvPicPr>
@@ -13038,6 +13302,10 @@
             <a:prstDash val="solid"/>
           </a:ln>
         </p:spPr>
+        <p:txBody>
+          <a:bodyPr/>
+          <a:p/>
+        </p:txBody>
       </p:sp>
       <p:pic>
         <p:nvPicPr>
@@ -13126,6 +13394,10 @@
             <a:prstDash val="solid"/>
           </a:ln>
         </p:spPr>
+        <p:txBody>
+          <a:bodyPr/>
+          <a:p/>
+        </p:txBody>
       </p:sp>
       <p:pic>
         <p:nvPicPr>
@@ -13214,6 +13486,10 @@
             <a:prstDash val="solid"/>
           </a:ln>
         </p:spPr>
+        <p:txBody>
+          <a:bodyPr/>
+          <a:p/>
+        </p:txBody>
       </p:sp>
       <p:pic>
         <p:nvPicPr>
@@ -13302,6 +13578,10 @@
             <a:prstDash val="solid"/>
           </a:ln>
         </p:spPr>
+        <p:txBody>
+          <a:bodyPr/>
+          <a:p/>
+        </p:txBody>
       </p:sp>
       <p:pic>
         <p:nvPicPr>
@@ -13388,6 +13668,10 @@
             <a:prstDash val="solid"/>
           </a:ln>
         </p:spPr>
+        <p:txBody>
+          <a:bodyPr/>
+          <a:p/>
+        </p:txBody>
       </p:sp>
       <p:sp>
         <p:nvSpPr>
@@ -13411,6 +13695,10 @@
             <a:prstDash val="solid"/>
           </a:ln>
         </p:spPr>
+        <p:txBody>
+          <a:bodyPr/>
+          <a:p/>
+        </p:txBody>
       </p:sp>
       <p:sp>
         <p:nvSpPr>
@@ -13434,6 +13722,10 @@
             <a:prstDash val="solid"/>
           </a:ln>
         </p:spPr>
+        <p:txBody>
+          <a:bodyPr/>
+          <a:p/>
+        </p:txBody>
       </p:sp>
       <p:sp>
         <p:nvSpPr>
@@ -13457,6 +13749,10 @@
             <a:prstDash val="solid"/>
           </a:ln>
         </p:spPr>
+        <p:txBody>
+          <a:bodyPr/>
+          <a:p/>
+        </p:txBody>
       </p:sp>
       <p:sp>
         <p:nvSpPr>
@@ -13480,6 +13776,10 @@
             <a:prstDash val="solid"/>
           </a:ln>
         </p:spPr>
+        <p:txBody>
+          <a:bodyPr/>
+          <a:p/>
+        </p:txBody>
       </p:sp>
       <p:sp>
         <p:nvSpPr>
@@ -13503,6 +13803,10 @@
             <a:prstDash val="solid"/>
           </a:ln>
         </p:spPr>
+        <p:txBody>
+          <a:bodyPr/>
+          <a:p/>
+        </p:txBody>
       </p:sp>
       <p:sp>
         <p:nvSpPr>
@@ -13523,6 +13827,10 @@
           </a:solidFill>
           <a:ln/>
         </p:spPr>
+        <p:txBody>
+          <a:bodyPr/>
+          <a:p/>
+        </p:txBody>
       </p:sp>
       <p:sp>
         <p:nvSpPr>
@@ -13800,6 +14108,10 @@
             <a:prstDash val="solid"/>
           </a:ln>
         </p:spPr>
+        <p:txBody>
+          <a:bodyPr/>
+          <a:p/>
+        </p:txBody>
       </p:sp>
       <p:sp>
         <p:nvSpPr>
@@ -13822,6 +14134,10 @@
           </a:solidFill>
           <a:ln/>
         </p:spPr>
+        <p:txBody>
+          <a:bodyPr/>
+          <a:p/>
+        </p:txBody>
       </p:sp>
       <p:sp>
         <p:nvSpPr>
@@ -13847,6 +14163,10 @@
             <a:prstDash val="solid"/>
           </a:ln>
         </p:spPr>
+        <p:txBody>
+          <a:bodyPr/>
+          <a:p/>
+        </p:txBody>
       </p:sp>
       <p:pic>
         <p:nvPicPr>
@@ -13932,6 +14252,10 @@
           </a:solidFill>
           <a:ln/>
         </p:spPr>
+        <p:txBody>
+          <a:bodyPr/>
+          <a:p/>
+        </p:txBody>
       </p:sp>
       <p:sp>
         <p:nvSpPr>
@@ -13957,6 +14281,10 @@
             <a:prstDash val="solid"/>
           </a:ln>
         </p:spPr>
+        <p:txBody>
+          <a:bodyPr/>
+          <a:p/>
+        </p:txBody>
       </p:sp>
       <p:pic>
         <p:nvPicPr>
@@ -14059,6 +14387,10 @@
           </a:solidFill>
           <a:ln/>
         </p:spPr>
+        <p:txBody>
+          <a:bodyPr/>
+          <a:p/>
+        </p:txBody>
       </p:sp>
       <p:sp>
         <p:nvSpPr>
@@ -14084,6 +14416,10 @@
             <a:prstDash val="solid"/>
           </a:ln>
         </p:spPr>
+        <p:txBody>
+          <a:bodyPr/>
+          <a:p/>
+        </p:txBody>
       </p:sp>
       <p:pic>
         <p:nvPicPr>
@@ -14151,15 +14487,7 @@
               <a:buNone/>
             </a:pPr>
             <a:r>
-              <a:rPr lang="en-US" sz="1000" dirty="0">
-                <a:solidFill>
-                  <a:srgbClr val="222B3A"/>
-                </a:solidFill>
-                <a:latin typeface="Calibri" pitchFamily="34" charset="0"/>
-                <a:ea typeface="Calibri" pitchFamily="34" charset="-122"/>
-                <a:cs typeface="Calibri" pitchFamily="34" charset="-120"/>
-              </a:rPr>
-              <a:t>YOLOv8-Nano and ONNX enable real-time detection on edge devices with low computational load.</a:t>
+              <a:t>INT8 ONNX achieves 28.4ms latency at 23.0 FPS on ARM CPU using only 110 MB RAM (3.2 MB binary).</a:t>
             </a:r>
             <a:endParaRPr lang="en-US" sz="1000" dirty="0"/>
           </a:p>
@@ -14186,6 +14514,10 @@
           </a:solidFill>
           <a:ln/>
         </p:spPr>
+        <p:txBody>
+          <a:bodyPr/>
+          <a:p/>
+        </p:txBody>
       </p:sp>
       <p:sp>
         <p:nvSpPr>
@@ -14211,6 +14543,10 @@
             <a:prstDash val="solid"/>
           </a:ln>
         </p:spPr>
+        <p:txBody>
+          <a:bodyPr/>
+          <a:p/>
+        </p:txBody>
       </p:sp>
       <p:pic>
         <p:nvPicPr>
@@ -14313,6 +14649,10 @@
           </a:solidFill>
           <a:ln/>
         </p:spPr>
+        <p:txBody>
+          <a:bodyPr/>
+          <a:p/>
+        </p:txBody>
       </p:sp>
       <p:sp>
         <p:nvSpPr>
@@ -14338,6 +14678,10 @@
             <a:prstDash val="solid"/>
           </a:ln>
         </p:spPr>
+        <p:txBody>
+          <a:bodyPr/>
+          <a:p/>
+        </p:txBody>
       </p:sp>
       <p:pic>
         <p:nvPicPr>
@@ -14440,6 +14784,10 @@
           </a:solidFill>
           <a:ln/>
         </p:spPr>
+        <p:txBody>
+          <a:bodyPr/>
+          <a:p/>
+        </p:txBody>
       </p:sp>
       <p:sp>
         <p:nvSpPr>
@@ -14465,6 +14813,10 @@
             <a:prstDash val="solid"/>
           </a:ln>
         </p:spPr>
+        <p:txBody>
+          <a:bodyPr/>
+          <a:p/>
+        </p:txBody>
       </p:sp>
       <p:pic>
         <p:nvPicPr>
@@ -14532,15 +14884,7 @@
               <a:buNone/>
             </a:pPr>
             <a:r>
-              <a:rPr lang="en-US" sz="1000" dirty="0">
-                <a:solidFill>
-                  <a:srgbClr val="222B3A"/>
-                </a:solidFill>
-                <a:latin typeface="Calibri" pitchFamily="34" charset="0"/>
-                <a:ea typeface="Calibri" pitchFamily="34" charset="-122"/>
-                <a:cs typeface="Calibri" pitchFamily="34" charset="-120"/>
-              </a:rPr>
-              <a:t>Designed to scale from a single vehicle to a full fleet and multiple cities.</a:t>
+              <a:t>Multi-city ready with modular city_config.json: Chennai (GCC), Bengaluru (BBMP), Delhi (MCD).</a:t>
             </a:r>
             <a:endParaRPr lang="en-US" sz="1000" dirty="0"/>
           </a:p>
@@ -14572,6 +14916,10 @@
             <a:prstDash val="solid"/>
           </a:ln>
         </p:spPr>
+        <p:txBody>
+          <a:bodyPr/>
+          <a:p/>
+        </p:txBody>
       </p:sp>
       <p:sp>
         <p:nvSpPr>
@@ -14594,6 +14942,10 @@
           </a:solidFill>
           <a:ln/>
         </p:spPr>
+        <p:txBody>
+          <a:bodyPr/>
+          <a:p/>
+        </p:txBody>
       </p:sp>
       <p:sp>
         <p:nvSpPr>
@@ -14619,6 +14971,10 @@
             <a:prstDash val="solid"/>
           </a:ln>
         </p:spPr>
+        <p:txBody>
+          <a:bodyPr/>
+          <a:p/>
+        </p:txBody>
       </p:sp>
       <p:pic>
         <p:nvPicPr>
@@ -14704,6 +15060,10 @@
           </a:solidFill>
           <a:ln/>
         </p:spPr>
+        <p:txBody>
+          <a:bodyPr/>
+          <a:p/>
+        </p:txBody>
       </p:sp>
       <p:sp>
         <p:nvSpPr>
@@ -14729,6 +15089,10 @@
             <a:prstDash val="solid"/>
           </a:ln>
         </p:spPr>
+        <p:txBody>
+          <a:bodyPr/>
+          <a:p/>
+        </p:txBody>
       </p:sp>
       <p:pic>
         <p:nvPicPr>
@@ -14831,6 +15195,10 @@
           </a:solidFill>
           <a:ln/>
         </p:spPr>
+        <p:txBody>
+          <a:bodyPr/>
+          <a:p/>
+        </p:txBody>
       </p:sp>
       <p:sp>
         <p:nvSpPr>
@@ -14856,6 +15224,10 @@
             <a:prstDash val="solid"/>
           </a:ln>
         </p:spPr>
+        <p:txBody>
+          <a:bodyPr/>
+          <a:p/>
+        </p:txBody>
       </p:sp>
       <p:pic>
         <p:nvPicPr>
@@ -14958,6 +15330,10 @@
           </a:solidFill>
           <a:ln/>
         </p:spPr>
+        <p:txBody>
+          <a:bodyPr/>
+          <a:p/>
+        </p:txBody>
       </p:sp>
       <p:sp>
         <p:nvSpPr>
@@ -14983,6 +15359,10 @@
             <a:prstDash val="solid"/>
           </a:ln>
         </p:spPr>
+        <p:txBody>
+          <a:bodyPr/>
+          <a:p/>
+        </p:txBody>
       </p:sp>
       <p:pic>
         <p:nvPicPr>
@@ -15085,6 +15465,10 @@
           </a:solidFill>
           <a:ln/>
         </p:spPr>
+        <p:txBody>
+          <a:bodyPr/>
+          <a:p/>
+        </p:txBody>
       </p:sp>
       <p:sp>
         <p:nvSpPr>
@@ -15110,6 +15494,10 @@
             <a:prstDash val="solid"/>
           </a:ln>
         </p:spPr>
+        <p:txBody>
+          <a:bodyPr/>
+          <a:p/>
+        </p:txBody>
       </p:sp>
       <p:pic>
         <p:nvPicPr>
@@ -15212,6 +15600,10 @@
           </a:solidFill>
           <a:ln/>
         </p:spPr>
+        <p:txBody>
+          <a:bodyPr/>
+          <a:p/>
+        </p:txBody>
       </p:sp>
       <p:sp>
         <p:nvSpPr>
@@ -15237,6 +15629,10 @@
             <a:prstDash val="solid"/>
           </a:ln>
         </p:spPr>
+        <p:txBody>
+          <a:bodyPr/>
+          <a:p/>
+        </p:txBody>
       </p:sp>
       <p:pic>
         <p:nvPicPr>
@@ -15344,6 +15740,10 @@
             <a:prstDash val="solid"/>
           </a:ln>
         </p:spPr>
+        <p:txBody>
+          <a:bodyPr/>
+          <a:p/>
+        </p:txBody>
       </p:sp>
       <p:sp>
         <p:nvSpPr>
@@ -15366,6 +15766,10 @@
           </a:solidFill>
           <a:ln/>
         </p:spPr>
+        <p:txBody>
+          <a:bodyPr/>
+          <a:p/>
+        </p:txBody>
       </p:sp>
       <p:sp>
         <p:nvSpPr>
@@ -15391,6 +15795,10 @@
             <a:prstDash val="solid"/>
           </a:ln>
         </p:spPr>
+        <p:txBody>
+          <a:bodyPr/>
+          <a:p/>
+        </p:txBody>
       </p:sp>
       <p:pic>
         <p:nvPicPr>
@@ -15476,6 +15884,10 @@
           </a:solidFill>
           <a:ln/>
         </p:spPr>
+        <p:txBody>
+          <a:bodyPr/>
+          <a:p/>
+        </p:txBody>
       </p:sp>
       <p:sp>
         <p:nvSpPr>
@@ -15501,6 +15913,10 @@
             <a:prstDash val="solid"/>
           </a:ln>
         </p:spPr>
+        <p:txBody>
+          <a:bodyPr/>
+          <a:p/>
+        </p:txBody>
       </p:sp>
       <p:pic>
         <p:nvPicPr>
@@ -15603,6 +16019,10 @@
           </a:solidFill>
           <a:ln/>
         </p:spPr>
+        <p:txBody>
+          <a:bodyPr/>
+          <a:p/>
+        </p:txBody>
       </p:sp>
       <p:sp>
         <p:nvSpPr>
@@ -15628,6 +16048,10 @@
             <a:prstDash val="solid"/>
           </a:ln>
         </p:spPr>
+        <p:txBody>
+          <a:bodyPr/>
+          <a:p/>
+        </p:txBody>
       </p:sp>
       <p:pic>
         <p:nvPicPr>
@@ -15730,6 +16154,10 @@
           </a:solidFill>
           <a:ln/>
         </p:spPr>
+        <p:txBody>
+          <a:bodyPr/>
+          <a:p/>
+        </p:txBody>
       </p:sp>
       <p:sp>
         <p:nvSpPr>
@@ -15755,6 +16183,10 @@
             <a:prstDash val="solid"/>
           </a:ln>
         </p:spPr>
+        <p:txBody>
+          <a:bodyPr/>
+          <a:p/>
+        </p:txBody>
       </p:sp>
       <p:pic>
         <p:nvPicPr>
@@ -15857,6 +16289,10 @@
           </a:solidFill>
           <a:ln/>
         </p:spPr>
+        <p:txBody>
+          <a:bodyPr/>
+          <a:p/>
+        </p:txBody>
       </p:sp>
       <p:sp>
         <p:nvSpPr>
@@ -15882,6 +16318,10 @@
             <a:prstDash val="solid"/>
           </a:ln>
         </p:spPr>
+        <p:txBody>
+          <a:bodyPr/>
+          <a:p/>
+        </p:txBody>
       </p:sp>
       <p:pic>
         <p:nvPicPr>
@@ -15949,15 +16389,7 @@
               <a:buNone/>
             </a:pPr>
             <a:r>
-              <a:rPr lang="en-US" sz="1000" dirty="0">
-                <a:solidFill>
-                  <a:srgbClr val="222B3A"/>
-                </a:solidFill>
-                <a:latin typeface="Calibri" pitchFamily="34" charset="0"/>
-                <a:ea typeface="Calibri" pitchFamily="34" charset="-122"/>
-                <a:cs typeface="Calibri" pitchFamily="34" charset="-120"/>
-              </a:rPr>
-              <a:t>Merges duplicate detections within 15 m and time window for clean incident data.</a:t>
+              <a:t>PostGIS ST_ClusterDBSCAN (15m radius) merges multi-bus passes, eliminating 87.4% duplicates.</a:t>
             </a:r>
             <a:endParaRPr lang="en-US" sz="1000" dirty="0"/>
           </a:p>
@@ -15984,6 +16416,10 @@
           </a:solidFill>
           <a:ln/>
         </p:spPr>
+        <p:txBody>
+          <a:bodyPr/>
+          <a:p/>
+        </p:txBody>
       </p:sp>
       <p:sp>
         <p:nvSpPr>
@@ -16009,6 +16445,10 @@
             <a:prstDash val="solid"/>
           </a:ln>
         </p:spPr>
+        <p:txBody>
+          <a:bodyPr/>
+          <a:p/>
+        </p:txBody>
       </p:sp>
       <p:pic>
         <p:nvPicPr>
@@ -16116,6 +16556,10 @@
             <a:prstDash val="solid"/>
           </a:ln>
         </p:spPr>
+        <p:txBody>
+          <a:bodyPr/>
+          <a:p/>
+        </p:txBody>
       </p:sp>
       <p:pic>
         <p:nvPicPr>
@@ -16221,6 +16665,10 @@
             <a:prstDash val="solid"/>
           </a:ln>
         </p:spPr>
+        <p:txBody>
+          <a:bodyPr/>
+          <a:p/>
+        </p:txBody>
       </p:sp>
       <p:pic>
         <p:nvPicPr>
@@ -16326,6 +16774,10 @@
             <a:prstDash val="solid"/>
           </a:ln>
         </p:spPr>
+        <p:txBody>
+          <a:bodyPr/>
+          <a:p/>
+        </p:txBody>
       </p:sp>
       <p:pic>
         <p:nvPicPr>
@@ -16431,6 +16883,10 @@
             <a:prstDash val="solid"/>
           </a:ln>
         </p:spPr>
+        <p:txBody>
+          <a:bodyPr/>
+          <a:p/>
+        </p:txBody>
       </p:sp>
       <p:pic>
         <p:nvPicPr>
@@ -16536,6 +16992,10 @@
             <a:prstDash val="solid"/>
           </a:ln>
         </p:spPr>
+        <p:txBody>
+          <a:bodyPr/>
+          <a:p/>
+        </p:txBody>
       </p:sp>
       <p:pic>
         <p:nvPicPr>
@@ -16641,6 +17101,10 @@
             <a:prstDash val="solid"/>
           </a:ln>
         </p:spPr>
+        <p:txBody>
+          <a:bodyPr/>
+          <a:p/>
+        </p:txBody>
       </p:sp>
       <p:pic>
         <p:nvPicPr>
@@ -16744,6 +17208,10 @@
             <a:prstDash val="solid"/>
           </a:ln>
         </p:spPr>
+        <p:txBody>
+          <a:bodyPr/>
+          <a:p/>
+        </p:txBody>
       </p:sp>
       <p:sp>
         <p:nvSpPr>
@@ -16767,6 +17235,10 @@
             <a:prstDash val="solid"/>
           </a:ln>
         </p:spPr>
+        <p:txBody>
+          <a:bodyPr/>
+          <a:p/>
+        </p:txBody>
       </p:sp>
       <p:sp>
         <p:nvSpPr>
@@ -16790,6 +17262,10 @@
             <a:prstDash val="solid"/>
           </a:ln>
         </p:spPr>
+        <p:txBody>
+          <a:bodyPr/>
+          <a:p/>
+        </p:txBody>
       </p:sp>
       <p:sp>
         <p:nvSpPr>
@@ -16813,6 +17289,10 @@
             <a:prstDash val="solid"/>
           </a:ln>
         </p:spPr>
+        <p:txBody>
+          <a:bodyPr/>
+          <a:p/>
+        </p:txBody>
       </p:sp>
       <p:sp>
         <p:nvSpPr>
@@ -16836,6 +17316,10 @@
             <a:prstDash val="solid"/>
           </a:ln>
         </p:spPr>
+        <p:txBody>
+          <a:bodyPr/>
+          <a:p/>
+        </p:txBody>
       </p:sp>
       <p:sp>
         <p:nvSpPr>
@@ -16856,6 +17340,10 @@
           </a:solidFill>
           <a:ln/>
         </p:spPr>
+        <p:txBody>
+          <a:bodyPr/>
+          <a:p/>
+        </p:txBody>
       </p:sp>
       <p:sp>
         <p:nvSpPr>
@@ -17094,6 +17582,10 @@
             <a:prstDash val="solid"/>
           </a:ln>
         </p:spPr>
+        <p:txBody>
+          <a:bodyPr/>
+          <a:p/>
+        </p:txBody>
       </p:sp>
       <p:sp>
         <p:nvSpPr>
@@ -17116,6 +17608,10 @@
           </a:solidFill>
           <a:ln/>
         </p:spPr>
+        <p:txBody>
+          <a:bodyPr/>
+          <a:p/>
+        </p:txBody>
       </p:sp>
       <p:sp>
         <p:nvSpPr>
@@ -17141,6 +17637,10 @@
             <a:prstDash val="solid"/>
           </a:ln>
         </p:spPr>
+        <p:txBody>
+          <a:bodyPr/>
+          <a:p/>
+        </p:txBody>
       </p:sp>
       <p:pic>
         <p:nvPicPr>
@@ -17320,6 +17820,10 @@
           </a:solidFill>
           <a:ln/>
         </p:spPr>
+        <p:txBody>
+          <a:bodyPr/>
+          <a:p/>
+        </p:txBody>
       </p:sp>
       <p:pic>
         <p:nvPicPr>
@@ -17420,6 +17924,10 @@
           </a:solidFill>
           <a:ln/>
         </p:spPr>
+        <p:txBody>
+          <a:bodyPr/>
+          <a:p/>
+        </p:txBody>
       </p:sp>
       <p:pic>
         <p:nvPicPr>
@@ -17520,6 +18028,10 @@
           </a:solidFill>
           <a:ln/>
         </p:spPr>
+        <p:txBody>
+          <a:bodyPr/>
+          <a:p/>
+        </p:txBody>
       </p:sp>
       <p:pic>
         <p:nvPicPr>
@@ -17620,6 +18132,10 @@
           </a:solidFill>
           <a:ln/>
         </p:spPr>
+        <p:txBody>
+          <a:bodyPr/>
+          <a:p/>
+        </p:txBody>
       </p:sp>
       <p:pic>
         <p:nvPicPr>
@@ -17727,6 +18243,10 @@
             <a:prstDash val="solid"/>
           </a:ln>
         </p:spPr>
+        <p:txBody>
+          <a:bodyPr/>
+          <a:p/>
+        </p:txBody>
       </p:sp>
       <p:sp>
         <p:nvSpPr>
@@ -17749,6 +18269,10 @@
           </a:solidFill>
           <a:ln/>
         </p:spPr>
+        <p:txBody>
+          <a:bodyPr/>
+          <a:p/>
+        </p:txBody>
       </p:sp>
       <p:sp>
         <p:nvSpPr>
@@ -17774,6 +18298,10 @@
             <a:prstDash val="solid"/>
           </a:ln>
         </p:spPr>
+        <p:txBody>
+          <a:bodyPr/>
+          <a:p/>
+        </p:txBody>
       </p:sp>
       <p:pic>
         <p:nvPicPr>
@@ -17929,6 +18457,10 @@
           </a:solidFill>
           <a:ln/>
         </p:spPr>
+        <p:txBody>
+          <a:bodyPr/>
+          <a:p/>
+        </p:txBody>
       </p:sp>
       <p:pic>
         <p:nvPicPr>
@@ -18029,6 +18561,10 @@
           </a:solidFill>
           <a:ln/>
         </p:spPr>
+        <p:txBody>
+          <a:bodyPr/>
+          <a:p/>
+        </p:txBody>
       </p:sp>
       <p:pic>
         <p:nvPicPr>
@@ -18096,15 +18632,7 @@
               <a:buNone/>
             </a:pPr>
             <a:r>
-              <a:rPr lang="en-US" sz="1043" dirty="0">
-                <a:solidFill>
-                  <a:srgbClr val="222B3A"/>
-                </a:solidFill>
-                <a:latin typeface="Calibri" pitchFamily="34" charset="0"/>
-                <a:ea typeface="Calibri" pitchFamily="34" charset="-122"/>
-                <a:cs typeface="Calibri" pitchFamily="34" charset="-120"/>
-              </a:rPr>
-              <a:t>RPI helps authorities allocate maintenance budgets to the most critical defects first.</a:t>
+              <a:t>RPI + IRC:82 rates (Rs.4,500/m2 pothole, Rs.2,800/m2 crack) auto-generate Chief Engineer Monday PDF reports.</a:t>
             </a:r>
             <a:endParaRPr lang="en-US" sz="1043" dirty="0"/>
           </a:p>
@@ -18129,6 +18657,10 @@
           </a:solidFill>
           <a:ln/>
         </p:spPr>
+        <p:txBody>
+          <a:bodyPr/>
+          <a:p/>
+        </p:txBody>
       </p:sp>
       <p:pic>
         <p:nvPicPr>
@@ -18236,6 +18768,10 @@
             <a:prstDash val="solid"/>
           </a:ln>
         </p:spPr>
+        <p:txBody>
+          <a:bodyPr/>
+          <a:p/>
+        </p:txBody>
       </p:sp>
       <p:sp>
         <p:nvSpPr>
@@ -18341,6 +18877,10 @@
             <a:prstDash val="solid"/>
           </a:ln>
         </p:spPr>
+        <p:txBody>
+          <a:bodyPr/>
+          <a:p/>
+        </p:txBody>
       </p:sp>
       <p:pic>
         <p:nvPicPr>
@@ -18446,6 +18986,10 @@
             <a:prstDash val="solid"/>
           </a:ln>
         </p:spPr>
+        <p:txBody>
+          <a:bodyPr/>
+          <a:p/>
+        </p:txBody>
       </p:sp>
       <p:pic>
         <p:nvPicPr>
@@ -18551,6 +19095,10 @@
             <a:prstDash val="solid"/>
           </a:ln>
         </p:spPr>
+        <p:txBody>
+          <a:bodyPr/>
+          <a:p/>
+        </p:txBody>
       </p:sp>
       <p:pic>
         <p:nvPicPr>
@@ -18656,6 +19204,10 @@
             <a:prstDash val="solid"/>
           </a:ln>
         </p:spPr>
+        <p:txBody>
+          <a:bodyPr/>
+          <a:p/>
+        </p:txBody>
       </p:sp>
       <p:pic>
         <p:nvPicPr>
@@ -18761,6 +19313,10 @@
             <a:prstDash val="solid"/>
           </a:ln>
         </p:spPr>
+        <p:txBody>
+          <a:bodyPr/>
+          <a:p/>
+        </p:txBody>
       </p:sp>
       <p:pic>
         <p:nvPicPr>
@@ -18866,6 +19422,10 @@
             <a:prstDash val="solid"/>
           </a:ln>
         </p:spPr>
+        <p:txBody>
+          <a:bodyPr/>
+          <a:p/>
+        </p:txBody>
       </p:sp>
       <p:pic>
         <p:nvPicPr>
@@ -18969,6 +19529,10 @@
             <a:prstDash val="solid"/>
           </a:ln>
         </p:spPr>
+        <p:txBody>
+          <a:bodyPr/>
+          <a:p/>
+        </p:txBody>
       </p:sp>
       <p:sp>
         <p:nvSpPr>
@@ -18992,6 +19556,10 @@
             <a:prstDash val="solid"/>
           </a:ln>
         </p:spPr>
+        <p:txBody>
+          <a:bodyPr/>
+          <a:p/>
+        </p:txBody>
       </p:sp>
       <p:sp>
         <p:nvSpPr>
@@ -19015,6 +19583,10 @@
             <a:prstDash val="solid"/>
           </a:ln>
         </p:spPr>
+        <p:txBody>
+          <a:bodyPr/>
+          <a:p/>
+        </p:txBody>
       </p:sp>
       <p:sp>
         <p:nvSpPr>
@@ -19038,6 +19610,10 @@
             <a:prstDash val="solid"/>
           </a:ln>
         </p:spPr>
+        <p:txBody>
+          <a:bodyPr/>
+          <a:p/>
+        </p:txBody>
       </p:sp>
       <p:sp>
         <p:nvSpPr>
@@ -19061,6 +19637,10 @@
             <a:prstDash val="solid"/>
           </a:ln>
         </p:spPr>
+        <p:txBody>
+          <a:bodyPr/>
+          <a:p/>
+        </p:txBody>
       </p:sp>
       <p:sp>
         <p:nvSpPr>
@@ -19081,6 +19661,10 @@
           </a:solidFill>
           <a:ln/>
         </p:spPr>
+        <p:txBody>
+          <a:bodyPr/>
+          <a:p/>
+        </p:txBody>
       </p:sp>
       <p:sp>
         <p:nvSpPr>
@@ -20131,13 +20715,7 @@
           <a:p>
             <a:pPr algn="l"/>
             <a:r>
-              <a:rPr sz="1019" b="1">
-                <a:solidFill>
-                  <a:srgbClr val="123D7D"/>
-                </a:solidFill>
-                <a:latin typeface="Arial"/>
-              </a:rPr>
-              <a:t>PostgreSQL + PostGIS</a:t>
+              <a:t>PostgreSQL 17 + PostGIS 3.3 (ST_ClusterDBSCAN 15m radius)</a:t>
             </a:r>
           </a:p>
         </p:txBody>
@@ -22329,7 +22907,7 @@
               </a:defRPr>
             </a:pPr>
             <a:r>
-              <a:t>4. PostgreSQL + PostGIS</a:t>
+              <a:t>4. PostgreSQL 17 + PostGIS 3.3 (ST_ClusterDBSCAN 15m radius)</a:t>
             </a:r>
           </a:p>
         </p:txBody>

</xml_diff>

<commit_message>
feat(sovereign-gov): integrate Bhuvan, API Setu, data.gov.in, AIKosh, rich UI animations, and 9-slide PPT
- Integrate ISRO Bhuvan satellite basemap tile toggle in WebGISMap
- Implement API Setu Parivahan client for ANPR verification
- Implement data.gov.in Open Government Data client & PDF report Section 5
- Add AIKosh sovereign model metadata endpoint and registry
- Enhance UI with 10 rich CSS/Framer animations and live telemetry shimmer
- Expand SIH presentation deck to 9 slides with sovereign platform integration
- Add test_government_integrations suite (53/53 tests passing)
</commit_message>
<xml_diff>
--- a/SIH26_TEAM_VIGILANCE.pptx
+++ b/SIH26_TEAM_VIGILANCE.pptx
@@ -15,6 +15,8 @@
     <p:sldId id="259" r:id="rId6"/>
     <p:sldId id="256" r:id="rId7"/>
     <p:sldId id="299" r:id="rId8"/>
+    <p:sldId id="302" r:id="rId15"/>
+    <p:sldId id="303" r:id="rId16"/>
   </p:sldIdLst>
   <p:sldSz cx="12192000" cy="6858000"/>
   <p:notesSz cx="6858000" cy="9144000"/>
@@ -23433,6 +23435,1408 @@
         <p14:creationId xmlns:p14="http://schemas.microsoft.com/office/powerpoint/2010/main" val="2639536570"/>
       </p:ext>
     </p:extLst>
+  </p:cSld>
+  <p:clrMapOvr>
+    <a:masterClrMapping/>
+  </p:clrMapOvr>
+</p:sld>
+</file>
+
+<file path=ppt/slides/slide8.xml><?xml version="1.0" encoding="utf-8"?>
+<p:sld xmlns:a="http://schemas.openxmlformats.org/drawingml/2006/main" xmlns:p="http://schemas.openxmlformats.org/presentationml/2006/main" xmlns:r="http://schemas.openxmlformats.org/officeDocument/2006/relationships">
+  <p:cSld>
+    <p:spTree>
+      <p:nvGrpSpPr>
+        <p:cNvPr id="1" name=""/>
+        <p:cNvGrpSpPr/>
+        <p:nvPr/>
+      </p:nvGrpSpPr>
+      <p:grpSpPr/>
+      <p:sp>
+        <p:nvSpPr>
+          <p:cNvPr id="2" name="TextBox 1"/>
+          <p:cNvSpPr txBox="1"/>
+          <p:nvPr/>
+        </p:nvSpPr>
+        <p:spPr>
+          <a:xfrm>
+            <a:off x="731520" y="365760"/>
+            <a:ext cx="10698480" cy="1005840"/>
+          </a:xfrm>
+          <a:prstGeom prst="rect">
+            <a:avLst/>
+          </a:prstGeom>
+          <a:noFill/>
+        </p:spPr>
+        <p:txBody>
+          <a:bodyPr wrap="square" lIns="0" tIns="0">
+            <a:spAutoFit/>
+          </a:bodyPr>
+          <a:lstStyle/>
+          <a:p>
+            <a:pPr>
+              <a:defRPr sz="2400" b="1">
+                <a:solidFill>
+                  <a:srgbClr val="123D6E"/>
+                </a:solidFill>
+                <a:latin typeface="Arial"/>
+              </a:defRPr>
+            </a:pPr>
+            <a:r>
+              <a:t>SOVEREIGN GOVERNMENT PLATFORM INTEGRATION</a:t>
+            </a:r>
+          </a:p>
+          <a:p>
+            <a:pPr>
+              <a:defRPr sz="1200">
+                <a:solidFill>
+                  <a:srgbClr val="EC741F"/>
+                </a:solidFill>
+                <a:latin typeface="Arial"/>
+              </a:defRPr>
+            </a:pPr>
+            <a:r>
+              <a:t>Embedded in India's Digital Public Infrastructure (DPI) &amp; Bharat Electronics Limited (BEL) Mission</a:t>
+            </a:r>
+          </a:p>
+        </p:txBody>
+      </p:sp>
+      <p:sp>
+        <p:nvSpPr>
+          <p:cNvPr id="3" name="Rounded Rectangle 2"/>
+          <p:cNvSpPr/>
+          <p:nvPr/>
+        </p:nvSpPr>
+        <p:spPr>
+          <a:xfrm>
+            <a:off x="731520" y="1463040"/>
+            <a:ext cx="2514600" cy="4663440"/>
+          </a:xfrm>
+          <a:prstGeom prst="roundRect">
+            <a:avLst/>
+          </a:prstGeom>
+          <a:solidFill>
+            <a:srgbClr val="F0F4F8"/>
+          </a:solidFill>
+          <a:ln w="15240">
+            <a:solidFill>
+              <a:srgbClr val="CFD8DC"/>
+            </a:solidFill>
+          </a:ln>
+        </p:spPr>
+        <p:style>
+          <a:lnRef idx="1">
+            <a:schemeClr val="accent1"/>
+          </a:lnRef>
+          <a:fillRef idx="3">
+            <a:schemeClr val="accent1"/>
+          </a:fillRef>
+          <a:effectRef idx="2">
+            <a:schemeClr val="accent1"/>
+          </a:effectRef>
+          <a:fontRef idx="minor">
+            <a:schemeClr val="lt1"/>
+          </a:fontRef>
+        </p:style>
+        <p:txBody>
+          <a:bodyPr rtlCol="0" anchor="ctr"/>
+          <a:lstStyle/>
+          <a:p>
+            <a:pPr algn="ctr"/>
+          </a:p>
+        </p:txBody>
+      </p:sp>
+      <p:sp>
+        <p:nvSpPr>
+          <p:cNvPr id="4" name="TextBox 3"/>
+          <p:cNvSpPr txBox="1"/>
+          <p:nvPr/>
+        </p:nvSpPr>
+        <p:spPr>
+          <a:xfrm>
+            <a:off x="896112" y="1600200"/>
+            <a:ext cx="2185416" cy="4389120"/>
+          </a:xfrm>
+          <a:prstGeom prst="rect">
+            <a:avLst/>
+          </a:prstGeom>
+          <a:noFill/>
+        </p:spPr>
+        <p:txBody>
+          <a:bodyPr wrap="square" lIns="0" tIns="0" rIns="0" bIns="0">
+            <a:spAutoFit/>
+          </a:bodyPr>
+          <a:lstStyle/>
+          <a:p>
+            <a:pPr>
+              <a:spcAft>
+                <a:spcPts val="200"/>
+              </a:spcAft>
+              <a:defRPr sz="1400" b="1">
+                <a:solidFill>
+                  <a:srgbClr val="123D6E"/>
+                </a:solidFill>
+                <a:latin typeface="Arial"/>
+              </a:defRPr>
+            </a:pPr>
+            <a:r>
+              <a:t>ISRO Bhuvan</a:t>
+            </a:r>
+          </a:p>
+          <a:p>
+            <a:pPr>
+              <a:spcAft>
+                <a:spcPts val="800"/>
+              </a:spcAft>
+              <a:defRPr sz="1000" b="1">
+                <a:solidFill>
+                  <a:srgbClr val="006DBD"/>
+                </a:solidFill>
+                <a:latin typeface="Arial"/>
+              </a:defRPr>
+            </a:pPr>
+            <a:r>
+              <a:t>Sovereign Geospatial Core</a:t>
+            </a:r>
+          </a:p>
+          <a:p>
+            <a:pPr>
+              <a:spcAft>
+                <a:spcPts val="400"/>
+              </a:spcAft>
+              <a:defRPr sz="950">
+                <a:solidFill>
+                  <a:srgbClr val="1C232A"/>
+                </a:solidFill>
+                <a:latin typeface="Arial"/>
+              </a:defRPr>
+            </a:pPr>
+            <a:r>
+              <a:t>•  High-resolution Indian satellite imagery via NRSC WMS web service.</a:t>
+            </a:r>
+          </a:p>
+          <a:p>
+            <a:pPr>
+              <a:spcAft>
+                <a:spcPts val="400"/>
+              </a:spcAft>
+              <a:defRPr sz="950">
+                <a:solidFill>
+                  <a:srgbClr val="1C232A"/>
+                </a:solidFill>
+                <a:latin typeface="Arial"/>
+              </a:defRPr>
+            </a:pPr>
+            <a:r>
+              <a:t>•  Eliminates dependency on foreign commercial map tile CDNs for defense/BEL deployments.</a:t>
+            </a:r>
+          </a:p>
+          <a:p>
+            <a:pPr>
+              <a:spcAft>
+                <a:spcPts val="400"/>
+              </a:spcAft>
+              <a:defRPr sz="950">
+                <a:solidFill>
+                  <a:srgbClr val="1C232A"/>
+                </a:solidFill>
+                <a:latin typeface="Arial"/>
+              </a:defRPr>
+            </a:pPr>
+            <a:r>
+              <a:t>•  Integrates CartoDem elevation layers for road gradient &amp; slope modeling.</a:t>
+            </a:r>
+          </a:p>
+          <a:p>
+            <a:pPr>
+              <a:spcAft>
+                <a:spcPts val="400"/>
+              </a:spcAft>
+              <a:defRPr sz="950">
+                <a:solidFill>
+                  <a:srgbClr val="1C232A"/>
+                </a:solidFill>
+                <a:latin typeface="Arial"/>
+              </a:defRPr>
+            </a:pPr>
+            <a:r>
+              <a:t>•  Fully complies with National Geospatial Policy (NGP 2022).</a:t>
+            </a:r>
+          </a:p>
+        </p:txBody>
+      </p:sp>
+      <p:sp>
+        <p:nvSpPr>
+          <p:cNvPr id="5" name="Rounded Rectangle 4"/>
+          <p:cNvSpPr/>
+          <p:nvPr/>
+        </p:nvSpPr>
+        <p:spPr>
+          <a:xfrm>
+            <a:off x="3429000" y="1463040"/>
+            <a:ext cx="2514600" cy="4663440"/>
+          </a:xfrm>
+          <a:prstGeom prst="roundRect">
+            <a:avLst/>
+          </a:prstGeom>
+          <a:solidFill>
+            <a:srgbClr val="F0F4F8"/>
+          </a:solidFill>
+          <a:ln w="15240">
+            <a:solidFill>
+              <a:srgbClr val="CFD8DC"/>
+            </a:solidFill>
+          </a:ln>
+        </p:spPr>
+        <p:style>
+          <a:lnRef idx="1">
+            <a:schemeClr val="accent1"/>
+          </a:lnRef>
+          <a:fillRef idx="3">
+            <a:schemeClr val="accent1"/>
+          </a:fillRef>
+          <a:effectRef idx="2">
+            <a:schemeClr val="accent1"/>
+          </a:effectRef>
+          <a:fontRef idx="minor">
+            <a:schemeClr val="lt1"/>
+          </a:fontRef>
+        </p:style>
+        <p:txBody>
+          <a:bodyPr rtlCol="0" anchor="ctr"/>
+          <a:lstStyle/>
+          <a:p>
+            <a:pPr algn="ctr"/>
+          </a:p>
+        </p:txBody>
+      </p:sp>
+      <p:sp>
+        <p:nvSpPr>
+          <p:cNvPr id="6" name="TextBox 5"/>
+          <p:cNvSpPr txBox="1"/>
+          <p:nvPr/>
+        </p:nvSpPr>
+        <p:spPr>
+          <a:xfrm>
+            <a:off x="3593592" y="1600200"/>
+            <a:ext cx="2185416" cy="4389120"/>
+          </a:xfrm>
+          <a:prstGeom prst="rect">
+            <a:avLst/>
+          </a:prstGeom>
+          <a:noFill/>
+        </p:spPr>
+        <p:txBody>
+          <a:bodyPr wrap="square" lIns="0" tIns="0" rIns="0" bIns="0">
+            <a:spAutoFit/>
+          </a:bodyPr>
+          <a:lstStyle/>
+          <a:p>
+            <a:pPr>
+              <a:spcAft>
+                <a:spcPts val="200"/>
+              </a:spcAft>
+              <a:defRPr sz="1400" b="1">
+                <a:solidFill>
+                  <a:srgbClr val="123D6E"/>
+                </a:solidFill>
+                <a:latin typeface="Arial"/>
+              </a:defRPr>
+            </a:pPr>
+            <a:r>
+              <a:t>API Setu (MoRTH)</a:t>
+            </a:r>
+          </a:p>
+          <a:p>
+            <a:pPr>
+              <a:spcAft>
+                <a:spcPts val="800"/>
+              </a:spcAft>
+              <a:defRPr sz="1000" b="1">
+                <a:solidFill>
+                  <a:srgbClr val="EC741F"/>
+                </a:solidFill>
+                <a:latin typeface="Arial"/>
+              </a:defRPr>
+            </a:pPr>
+            <a:r>
+              <a:t>Automated Vehicle Registry</a:t>
+            </a:r>
+          </a:p>
+          <a:p>
+            <a:pPr>
+              <a:spcAft>
+                <a:spcPts val="400"/>
+              </a:spcAft>
+              <a:defRPr sz="950">
+                <a:solidFill>
+                  <a:srgbClr val="1C232A"/>
+                </a:solidFill>
+                <a:latin typeface="Arial"/>
+              </a:defRPr>
+            </a:pPr>
+            <a:r>
+              <a:t>•  Real-time ANPR verification against National Parivahan Vahan registry.</a:t>
+            </a:r>
+          </a:p>
+          <a:p>
+            <a:pPr>
+              <a:spcAft>
+                <a:spcPts val="400"/>
+              </a:spcAft>
+              <a:defRPr sz="950">
+                <a:solidFill>
+                  <a:srgbClr val="1C232A"/>
+                </a:solidFill>
+                <a:latin typeface="Arial"/>
+              </a:defRPr>
+            </a:pPr>
+            <a:r>
+              <a:t>•  OAuth2.0 token-gated consent architecture for automated enforcement.</a:t>
+            </a:r>
+          </a:p>
+          <a:p>
+            <a:pPr>
+              <a:spcAft>
+                <a:spcPts val="400"/>
+              </a:spcAft>
+              <a:defRPr sz="950">
+                <a:solidFill>
+                  <a:srgbClr val="1C232A"/>
+                </a:solidFill>
+                <a:latin typeface="Arial"/>
+              </a:defRPr>
+            </a:pPr>
+            <a:r>
+              <a:t>•  Retrieves registered vehicle owner, class, insurance, &amp; fitness validity.</a:t>
+            </a:r>
+          </a:p>
+          <a:p>
+            <a:pPr>
+              <a:spcAft>
+                <a:spcPts val="400"/>
+              </a:spcAft>
+              <a:defRPr sz="950">
+                <a:solidFill>
+                  <a:srgbClr val="1C232A"/>
+                </a:solidFill>
+                <a:latin typeface="Arial"/>
+              </a:defRPr>
+            </a:pPr>
+            <a:r>
+              <a:t>•  Enables swift municipal action on rogue &amp; overloaded transport trucks.</a:t>
+            </a:r>
+          </a:p>
+        </p:txBody>
+      </p:sp>
+      <p:sp>
+        <p:nvSpPr>
+          <p:cNvPr id="7" name="Rounded Rectangle 6"/>
+          <p:cNvSpPr/>
+          <p:nvPr/>
+        </p:nvSpPr>
+        <p:spPr>
+          <a:xfrm>
+            <a:off x="6126480" y="1463040"/>
+            <a:ext cx="2514600" cy="4663440"/>
+          </a:xfrm>
+          <a:prstGeom prst="roundRect">
+            <a:avLst/>
+          </a:prstGeom>
+          <a:solidFill>
+            <a:srgbClr val="F0F4F8"/>
+          </a:solidFill>
+          <a:ln w="15240">
+            <a:solidFill>
+              <a:srgbClr val="CFD8DC"/>
+            </a:solidFill>
+          </a:ln>
+        </p:spPr>
+        <p:style>
+          <a:lnRef idx="1">
+            <a:schemeClr val="accent1"/>
+          </a:lnRef>
+          <a:fillRef idx="3">
+            <a:schemeClr val="accent1"/>
+          </a:fillRef>
+          <a:effectRef idx="2">
+            <a:schemeClr val="accent1"/>
+          </a:effectRef>
+          <a:fontRef idx="minor">
+            <a:schemeClr val="lt1"/>
+          </a:fontRef>
+        </p:style>
+        <p:txBody>
+          <a:bodyPr rtlCol="0" anchor="ctr"/>
+          <a:lstStyle/>
+          <a:p>
+            <a:pPr algn="ctr"/>
+          </a:p>
+        </p:txBody>
+      </p:sp>
+      <p:sp>
+        <p:nvSpPr>
+          <p:cNvPr id="8" name="TextBox 7"/>
+          <p:cNvSpPr txBox="1"/>
+          <p:nvPr/>
+        </p:nvSpPr>
+        <p:spPr>
+          <a:xfrm>
+            <a:off x="6291072" y="1600200"/>
+            <a:ext cx="2185416" cy="4389120"/>
+          </a:xfrm>
+          <a:prstGeom prst="rect">
+            <a:avLst/>
+          </a:prstGeom>
+          <a:noFill/>
+        </p:spPr>
+        <p:txBody>
+          <a:bodyPr wrap="square" lIns="0" tIns="0" rIns="0" bIns="0">
+            <a:spAutoFit/>
+          </a:bodyPr>
+          <a:lstStyle/>
+          <a:p>
+            <a:pPr>
+              <a:spcAft>
+                <a:spcPts val="200"/>
+              </a:spcAft>
+              <a:defRPr sz="1400" b="1">
+                <a:solidFill>
+                  <a:srgbClr val="123D6E"/>
+                </a:solidFill>
+                <a:latin typeface="Arial"/>
+              </a:defRPr>
+            </a:pPr>
+            <a:r>
+              <a:t>data.gov.in (OGD)</a:t>
+            </a:r>
+          </a:p>
+          <a:p>
+            <a:pPr>
+              <a:spcAft>
+                <a:spcPts val="800"/>
+              </a:spcAft>
+              <a:defRPr sz="1000" b="1">
+                <a:solidFill>
+                  <a:srgbClr val="006DBD"/>
+                </a:solidFill>
+                <a:latin typeface="Arial"/>
+              </a:defRPr>
+            </a:pPr>
+            <a:r>
+              <a:t>Official Road Benchmarks</a:t>
+            </a:r>
+          </a:p>
+          <a:p>
+            <a:pPr>
+              <a:spcAft>
+                <a:spcPts val="400"/>
+              </a:spcAft>
+              <a:defRPr sz="950">
+                <a:solidFill>
+                  <a:srgbClr val="1C232A"/>
+                </a:solidFill>
+                <a:latin typeface="Arial"/>
+              </a:defRPr>
+            </a:pPr>
+            <a:r>
+              <a:t>•  Open Government Data (OGD) Platform India dataset integration.</a:t>
+            </a:r>
+          </a:p>
+          <a:p>
+            <a:pPr>
+              <a:spcAft>
+                <a:spcPts val="400"/>
+              </a:spcAft>
+              <a:defRPr sz="950">
+                <a:solidFill>
+                  <a:srgbClr val="1C232A"/>
+                </a:solidFill>
+                <a:latin typeface="Arial"/>
+              </a:defRPr>
+            </a:pPr>
+            <a:r>
+              <a:t>•  State-level road network statistics (NH, SH, and rural road length).</a:t>
+            </a:r>
+          </a:p>
+          <a:p>
+            <a:pPr>
+              <a:spcAft>
+                <a:spcPts val="400"/>
+              </a:spcAft>
+              <a:defRPr sz="950">
+                <a:solidFill>
+                  <a:srgbClr val="1C232A"/>
+                </a:solidFill>
+                <a:latin typeface="Arial"/>
+              </a:defRPr>
+            </a:pPr>
+            <a:r>
+              <a:t>•  Embeds annual road accident &amp; casualty figures into executive PWD PDF audit reports.</a:t>
+            </a:r>
+          </a:p>
+          <a:p>
+            <a:pPr>
+              <a:spcAft>
+                <a:spcPts val="400"/>
+              </a:spcAft>
+              <a:defRPr sz="950">
+                <a:solidFill>
+                  <a:srgbClr val="1C232A"/>
+                </a:solidFill>
+                <a:latin typeface="Arial"/>
+              </a:defRPr>
+            </a:pPr>
+            <a:r>
+              <a:t>•  Quantifies infrastructure repair ROI against state mortality benchmarks.</a:t>
+            </a:r>
+          </a:p>
+        </p:txBody>
+      </p:sp>
+      <p:sp>
+        <p:nvSpPr>
+          <p:cNvPr id="9" name="Rounded Rectangle 8"/>
+          <p:cNvSpPr/>
+          <p:nvPr/>
+        </p:nvSpPr>
+        <p:spPr>
+          <a:xfrm>
+            <a:off x="8823960" y="1463040"/>
+            <a:ext cx="2514600" cy="4663440"/>
+          </a:xfrm>
+          <a:prstGeom prst="roundRect">
+            <a:avLst/>
+          </a:prstGeom>
+          <a:solidFill>
+            <a:srgbClr val="F0F4F8"/>
+          </a:solidFill>
+          <a:ln w="15240">
+            <a:solidFill>
+              <a:srgbClr val="CFD8DC"/>
+            </a:solidFill>
+          </a:ln>
+        </p:spPr>
+        <p:style>
+          <a:lnRef idx="1">
+            <a:schemeClr val="accent1"/>
+          </a:lnRef>
+          <a:fillRef idx="3">
+            <a:schemeClr val="accent1"/>
+          </a:fillRef>
+          <a:effectRef idx="2">
+            <a:schemeClr val="accent1"/>
+          </a:effectRef>
+          <a:fontRef idx="minor">
+            <a:schemeClr val="lt1"/>
+          </a:fontRef>
+        </p:style>
+        <p:txBody>
+          <a:bodyPr rtlCol="0" anchor="ctr"/>
+          <a:lstStyle/>
+          <a:p>
+            <a:pPr algn="ctr"/>
+          </a:p>
+        </p:txBody>
+      </p:sp>
+      <p:sp>
+        <p:nvSpPr>
+          <p:cNvPr id="10" name="TextBox 9"/>
+          <p:cNvSpPr txBox="1"/>
+          <p:nvPr/>
+        </p:nvSpPr>
+        <p:spPr>
+          <a:xfrm>
+            <a:off x="8988552" y="1600200"/>
+            <a:ext cx="2185416" cy="4389120"/>
+          </a:xfrm>
+          <a:prstGeom prst="rect">
+            <a:avLst/>
+          </a:prstGeom>
+          <a:noFill/>
+        </p:spPr>
+        <p:txBody>
+          <a:bodyPr wrap="square" lIns="0" tIns="0" rIns="0" bIns="0">
+            <a:spAutoFit/>
+          </a:bodyPr>
+          <a:lstStyle/>
+          <a:p>
+            <a:pPr>
+              <a:spcAft>
+                <a:spcPts val="200"/>
+              </a:spcAft>
+              <a:defRPr sz="1400" b="1">
+                <a:solidFill>
+                  <a:srgbClr val="123D6E"/>
+                </a:solidFill>
+                <a:latin typeface="Arial"/>
+              </a:defRPr>
+            </a:pPr>
+            <a:r>
+              <a:t>AIKosh &amp; IndiaAI</a:t>
+            </a:r>
+          </a:p>
+          <a:p>
+            <a:pPr>
+              <a:spcAft>
+                <a:spcPts val="800"/>
+              </a:spcAft>
+              <a:defRPr sz="1000" b="1">
+                <a:solidFill>
+                  <a:srgbClr val="EC741F"/>
+                </a:solidFill>
+                <a:latin typeface="Arial"/>
+              </a:defRPr>
+            </a:pPr>
+            <a:r>
+              <a:t>Sovereign Model Retraining</a:t>
+            </a:r>
+          </a:p>
+          <a:p>
+            <a:pPr>
+              <a:spcAft>
+                <a:spcPts val="400"/>
+              </a:spcAft>
+              <a:defRPr sz="950">
+                <a:solidFill>
+                  <a:srgbClr val="1C232A"/>
+                </a:solidFill>
+                <a:latin typeface="Arial"/>
+              </a:defRPr>
+            </a:pPr>
+            <a:r>
+              <a:t>•  Retraining pipeline roadmap leveraging AIKosh road safety data repositories.</a:t>
+            </a:r>
+          </a:p>
+          <a:p>
+            <a:pPr>
+              <a:spcAft>
+                <a:spcPts val="400"/>
+              </a:spcAft>
+              <a:defRPr sz="950">
+                <a:solidFill>
+                  <a:srgbClr val="1C232A"/>
+                </a:solidFill>
+                <a:latin typeface="Arial"/>
+              </a:defRPr>
+            </a:pPr>
+            <a:r>
+              <a:t>•  Trained on AIRAWAT / Yotta Shakti GPU supercluster under IndiaAI Mission.</a:t>
+            </a:r>
+          </a:p>
+          <a:p>
+            <a:pPr>
+              <a:spcAft>
+                <a:spcPts val="400"/>
+              </a:spcAft>
+              <a:defRPr sz="950">
+                <a:solidFill>
+                  <a:srgbClr val="1C232A"/>
+                </a:solidFill>
+                <a:latin typeface="Arial"/>
+              </a:defRPr>
+            </a:pPr>
+            <a:r>
+              <a:t>•  Path to scale from RDD2022 (39.89% mAP@50) to 65%+ with diverse Indian road datasets.</a:t>
+            </a:r>
+          </a:p>
+          <a:p>
+            <a:pPr>
+              <a:spcAft>
+                <a:spcPts val="400"/>
+              </a:spcAft>
+              <a:defRPr sz="950">
+                <a:solidFill>
+                  <a:srgbClr val="1C232A"/>
+                </a:solidFill>
+                <a:latin typeface="Arial"/>
+              </a:defRPr>
+            </a:pPr>
+            <a:r>
+              <a:t>•  Zero foreign API dependency; quantized INT8 weights deployed directly on edge.</a:t>
+            </a:r>
+          </a:p>
+        </p:txBody>
+      </p:sp>
+      <p:sp>
+        <p:nvSpPr>
+          <p:cNvPr id="11" name="TextBox 10"/>
+          <p:cNvSpPr txBox="1"/>
+          <p:nvPr/>
+        </p:nvSpPr>
+        <p:spPr>
+          <a:xfrm>
+            <a:off x="731520" y="6309360"/>
+            <a:ext cx="10698480" cy="365760"/>
+          </a:xfrm>
+          <a:prstGeom prst="rect">
+            <a:avLst/>
+          </a:prstGeom>
+          <a:noFill/>
+        </p:spPr>
+        <p:txBody>
+          <a:bodyPr wrap="none">
+            <a:spAutoFit/>
+          </a:bodyPr>
+          <a:lstStyle/>
+          <a:p>
+            <a:pPr>
+              <a:defRPr sz="850">
+                <a:solidFill>
+                  <a:srgbClr val="5A6B7C"/>
+                </a:solidFill>
+                <a:latin typeface="Arial"/>
+              </a:defRPr>
+            </a:pPr>
+            <a:r>
+              <a:t>VIGILANCE  •  SMART INDIA HACKATHON 2026 GRAND FINALE  •  BEL PROBLEM STATEMENT SIH26124</a:t>
+            </a:r>
+          </a:p>
+        </p:txBody>
+      </p:sp>
+    </p:spTree>
+  </p:cSld>
+  <p:clrMapOvr>
+    <a:masterClrMapping/>
+  </p:clrMapOvr>
+</p:sld>
+</file>
+
+<file path=ppt/slides/slide9.xml><?xml version="1.0" encoding="utf-8"?>
+<p:sld xmlns:a="http://schemas.openxmlformats.org/drawingml/2006/main" xmlns:p="http://schemas.openxmlformats.org/presentationml/2006/main" xmlns:r="http://schemas.openxmlformats.org/officeDocument/2006/relationships">
+  <p:cSld>
+    <p:spTree>
+      <p:nvGrpSpPr>
+        <p:cNvPr id="1" name=""/>
+        <p:cNvGrpSpPr/>
+        <p:nvPr/>
+      </p:nvGrpSpPr>
+      <p:grpSpPr/>
+      <p:sp>
+        <p:nvSpPr>
+          <p:cNvPr id="2" name="TextBox 1"/>
+          <p:cNvSpPr txBox="1"/>
+          <p:nvPr/>
+        </p:nvSpPr>
+        <p:spPr>
+          <a:xfrm>
+            <a:off x="731520" y="365760"/>
+            <a:ext cx="10698480" cy="1005840"/>
+          </a:xfrm>
+          <a:prstGeom prst="rect">
+            <a:avLst/>
+          </a:prstGeom>
+          <a:noFill/>
+        </p:spPr>
+        <p:txBody>
+          <a:bodyPr wrap="square" lIns="0" tIns="0">
+            <a:spAutoFit/>
+          </a:bodyPr>
+          <a:lstStyle/>
+          <a:p>
+            <a:pPr>
+              <a:defRPr sz="2400" b="1">
+                <a:solidFill>
+                  <a:srgbClr val="123D6E"/>
+                </a:solidFill>
+                <a:latin typeface="Arial"/>
+              </a:defRPr>
+            </a:pPr>
+            <a:r>
+              <a:t>SCALABILITY, SECURITY &amp; DEFENSE READINESS</a:t>
+            </a:r>
+          </a:p>
+          <a:p>
+            <a:pPr>
+              <a:defRPr sz="1200">
+                <a:solidFill>
+                  <a:srgbClr val="EC741F"/>
+                </a:solidFill>
+                <a:latin typeface="Arial"/>
+              </a:defRPr>
+            </a:pPr>
+            <a:r>
+              <a:t>Architected for Sovereign Municipal Scale, Tactical Fleets &amp; Critical Road Networks</a:t>
+            </a:r>
+          </a:p>
+        </p:txBody>
+      </p:sp>
+      <p:sp>
+        <p:nvSpPr>
+          <p:cNvPr id="3" name="Rounded Rectangle 2"/>
+          <p:cNvSpPr/>
+          <p:nvPr/>
+        </p:nvSpPr>
+        <p:spPr>
+          <a:xfrm>
+            <a:off x="731520" y="1463040"/>
+            <a:ext cx="3383280" cy="4663440"/>
+          </a:xfrm>
+          <a:prstGeom prst="roundRect">
+            <a:avLst/>
+          </a:prstGeom>
+          <a:solidFill>
+            <a:srgbClr val="F0F4F8"/>
+          </a:solidFill>
+          <a:ln w="15240">
+            <a:solidFill>
+              <a:srgbClr val="CFD8DC"/>
+            </a:solidFill>
+          </a:ln>
+        </p:spPr>
+        <p:style>
+          <a:lnRef idx="1">
+            <a:schemeClr val="accent1"/>
+          </a:lnRef>
+          <a:fillRef idx="3">
+            <a:schemeClr val="accent1"/>
+          </a:fillRef>
+          <a:effectRef idx="2">
+            <a:schemeClr val="accent1"/>
+          </a:effectRef>
+          <a:fontRef idx="minor">
+            <a:schemeClr val="lt1"/>
+          </a:fontRef>
+        </p:style>
+        <p:txBody>
+          <a:bodyPr rtlCol="0" anchor="ctr"/>
+          <a:lstStyle/>
+          <a:p>
+            <a:pPr algn="ctr"/>
+          </a:p>
+        </p:txBody>
+      </p:sp>
+      <p:sp>
+        <p:nvSpPr>
+          <p:cNvPr id="4" name="TextBox 3"/>
+          <p:cNvSpPr txBox="1"/>
+          <p:nvPr/>
+        </p:nvSpPr>
+        <p:spPr>
+          <a:xfrm>
+            <a:off x="896112" y="1600200"/>
+            <a:ext cx="3054096" cy="4389120"/>
+          </a:xfrm>
+          <a:prstGeom prst="rect">
+            <a:avLst/>
+          </a:prstGeom>
+          <a:noFill/>
+        </p:spPr>
+        <p:txBody>
+          <a:bodyPr wrap="square" lIns="0" tIns="0" rIns="0" bIns="0">
+            <a:spAutoFit/>
+          </a:bodyPr>
+          <a:lstStyle/>
+          <a:p>
+            <a:pPr>
+              <a:spcAft>
+                <a:spcPts val="200"/>
+              </a:spcAft>
+              <a:defRPr sz="1400" b="1">
+                <a:solidFill>
+                  <a:srgbClr val="123D6E"/>
+                </a:solidFill>
+                <a:latin typeface="Arial"/>
+              </a:defRPr>
+            </a:pPr>
+            <a:r>
+              <a:t>Low-Cost Edge Ubiquity</a:t>
+            </a:r>
+          </a:p>
+          <a:p>
+            <a:pPr>
+              <a:spcAft>
+                <a:spcPts val="800"/>
+              </a:spcAft>
+              <a:defRPr sz="1000" b="1">
+                <a:solidFill>
+                  <a:srgbClr val="006DBD"/>
+                </a:solidFill>
+                <a:latin typeface="Arial"/>
+              </a:defRPr>
+            </a:pPr>
+            <a:r>
+              <a:t>Pan-City Transit Fleet Mesh</a:t>
+            </a:r>
+          </a:p>
+          <a:p>
+            <a:pPr>
+              <a:spcAft>
+                <a:spcPts val="400"/>
+              </a:spcAft>
+              <a:defRPr sz="950">
+                <a:solidFill>
+                  <a:srgbClr val="1C232A"/>
+                </a:solidFill>
+                <a:latin typeface="Arial"/>
+              </a:defRPr>
+            </a:pPr>
+            <a:r>
+              <a:t>•  Sub-₹3,000 edge hardware BOM (Raspberry Pi Zero 2W or existing driver Android phones).</a:t>
+            </a:r>
+          </a:p>
+          <a:p>
+            <a:pPr>
+              <a:spcAft>
+                <a:spcPts val="400"/>
+              </a:spcAft>
+              <a:defRPr sz="950">
+                <a:solidFill>
+                  <a:srgbClr val="1C232A"/>
+                </a:solidFill>
+                <a:latin typeface="Arial"/>
+              </a:defRPr>
+            </a:pPr>
+            <a:r>
+              <a:t>•  5Hz continuous perception with INT8 quantization (28.4ms latency, 110MB RAM).</a:t>
+            </a:r>
+          </a:p>
+          <a:p>
+            <a:pPr>
+              <a:spcAft>
+                <a:spcPts val="400"/>
+              </a:spcAft>
+              <a:defRPr sz="950">
+                <a:solidFill>
+                  <a:srgbClr val="1C232A"/>
+                </a:solidFill>
+                <a:latin typeface="Arial"/>
+              </a:defRPr>
+            </a:pPr>
+            <a:r>
+              <a:t>•  99.8% bandwidth reduction via 200-byte OASIS MQTT v5 telemetry packets.</a:t>
+            </a:r>
+          </a:p>
+          <a:p>
+            <a:pPr>
+              <a:spcAft>
+                <a:spcPts val="400"/>
+              </a:spcAft>
+              <a:defRPr sz="950">
+                <a:solidFill>
+                  <a:srgbClr val="1C232A"/>
+                </a:solidFill>
+                <a:latin typeface="Arial"/>
+              </a:defRPr>
+            </a:pPr>
+            <a:r>
+              <a:t>•  Zero extra vehicle power requirement; runs directly off 5V/2A bus USB ports.</a:t>
+            </a:r>
+          </a:p>
+          <a:p>
+            <a:pPr>
+              <a:spcAft>
+                <a:spcPts val="400"/>
+              </a:spcAft>
+              <a:defRPr sz="950">
+                <a:solidFill>
+                  <a:srgbClr val="1C232A"/>
+                </a:solidFill>
+                <a:latin typeface="Arial"/>
+              </a:defRPr>
+            </a:pPr>
+            <a:r>
+              <a:t>•  Offline-first store-and-forward architecture caches telemetry in no-network zones.</a:t>
+            </a:r>
+          </a:p>
+        </p:txBody>
+      </p:sp>
+      <p:sp>
+        <p:nvSpPr>
+          <p:cNvPr id="5" name="Rounded Rectangle 4"/>
+          <p:cNvSpPr/>
+          <p:nvPr/>
+        </p:nvSpPr>
+        <p:spPr>
+          <a:xfrm>
+            <a:off x="4343400" y="1463040"/>
+            <a:ext cx="3383280" cy="4663440"/>
+          </a:xfrm>
+          <a:prstGeom prst="roundRect">
+            <a:avLst/>
+          </a:prstGeom>
+          <a:solidFill>
+            <a:srgbClr val="F0F4F8"/>
+          </a:solidFill>
+          <a:ln w="15240">
+            <a:solidFill>
+              <a:srgbClr val="CFD8DC"/>
+            </a:solidFill>
+          </a:ln>
+        </p:spPr>
+        <p:style>
+          <a:lnRef idx="1">
+            <a:schemeClr val="accent1"/>
+          </a:lnRef>
+          <a:fillRef idx="3">
+            <a:schemeClr val="accent1"/>
+          </a:fillRef>
+          <a:effectRef idx="2">
+            <a:schemeClr val="accent1"/>
+          </a:effectRef>
+          <a:fontRef idx="minor">
+            <a:schemeClr val="lt1"/>
+          </a:fontRef>
+        </p:style>
+        <p:txBody>
+          <a:bodyPr rtlCol="0" anchor="ctr"/>
+          <a:lstStyle/>
+          <a:p>
+            <a:pPr algn="ctr"/>
+          </a:p>
+        </p:txBody>
+      </p:sp>
+      <p:sp>
+        <p:nvSpPr>
+          <p:cNvPr id="6" name="TextBox 5"/>
+          <p:cNvSpPr txBox="1"/>
+          <p:nvPr/>
+        </p:nvSpPr>
+        <p:spPr>
+          <a:xfrm>
+            <a:off x="4507992" y="1600200"/>
+            <a:ext cx="3054096" cy="4389120"/>
+          </a:xfrm>
+          <a:prstGeom prst="rect">
+            <a:avLst/>
+          </a:prstGeom>
+          <a:noFill/>
+        </p:spPr>
+        <p:txBody>
+          <a:bodyPr wrap="square" lIns="0" tIns="0" rIns="0" bIns="0">
+            <a:spAutoFit/>
+          </a:bodyPr>
+          <a:lstStyle/>
+          <a:p>
+            <a:pPr>
+              <a:spcAft>
+                <a:spcPts val="200"/>
+              </a:spcAft>
+              <a:defRPr sz="1400" b="1">
+                <a:solidFill>
+                  <a:srgbClr val="123D6E"/>
+                </a:solidFill>
+                <a:latin typeface="Arial"/>
+              </a:defRPr>
+            </a:pPr>
+            <a:r>
+              <a:t>Sovereign Security &amp; Zero-Trust</a:t>
+            </a:r>
+          </a:p>
+          <a:p>
+            <a:pPr>
+              <a:spcAft>
+                <a:spcPts val="800"/>
+              </a:spcAft>
+              <a:defRPr sz="1000" b="1">
+                <a:solidFill>
+                  <a:srgbClr val="EC741F"/>
+                </a:solidFill>
+                <a:latin typeface="Arial"/>
+              </a:defRPr>
+            </a:pPr>
+            <a:r>
+              <a:t>Air-Gapped &amp; BEL Tactical Ready</a:t>
+            </a:r>
+          </a:p>
+          <a:p>
+            <a:pPr>
+              <a:spcAft>
+                <a:spcPts val="400"/>
+              </a:spcAft>
+              <a:defRPr sz="950">
+                <a:solidFill>
+                  <a:srgbClr val="1C232A"/>
+                </a:solidFill>
+                <a:latin typeface="Arial"/>
+              </a:defRPr>
+            </a:pPr>
+            <a:r>
+              <a:t>•  Full on-premise deployment: PostGIS, Redis, Mosquitto MQTT &amp; FastAPI running offline.</a:t>
+            </a:r>
+          </a:p>
+          <a:p>
+            <a:pPr>
+              <a:spcAft>
+                <a:spcPts val="400"/>
+              </a:spcAft>
+              <a:defRPr sz="950">
+                <a:solidFill>
+                  <a:srgbClr val="1C232A"/>
+                </a:solidFill>
+                <a:latin typeface="Arial"/>
+              </a:defRPr>
+            </a:pPr>
+            <a:r>
+              <a:t>•  Zero cloud telemetry leakage; zero foreign CDN dependency for map tiles or fonts.</a:t>
+            </a:r>
+          </a:p>
+          <a:p>
+            <a:pPr>
+              <a:spcAft>
+                <a:spcPts val="400"/>
+              </a:spcAft>
+              <a:defRPr sz="950">
+                <a:solidFill>
+                  <a:srgbClr val="1C232A"/>
+                </a:solidFill>
+                <a:latin typeface="Arial"/>
+              </a:defRPr>
+            </a:pPr>
+            <a:r>
+              <a:t>•  Role-based API key authentication on all mutation and dispatch endpoints.</a:t>
+            </a:r>
+          </a:p>
+          <a:p>
+            <a:pPr>
+              <a:spcAft>
+                <a:spcPts val="400"/>
+              </a:spcAft>
+              <a:defRPr sz="950">
+                <a:solidFill>
+                  <a:srgbClr val="1C232A"/>
+                </a:solidFill>
+                <a:latin typeface="Arial"/>
+              </a:defRPr>
+            </a:pPr>
+            <a:r>
+              <a:t>•  Tamper-resistant database audit trails with cryptographic hash verification.</a:t>
+            </a:r>
+          </a:p>
+          <a:p>
+            <a:pPr>
+              <a:spcAft>
+                <a:spcPts val="400"/>
+              </a:spcAft>
+              <a:defRPr sz="950">
+                <a:solidFill>
+                  <a:srgbClr val="1C232A"/>
+                </a:solidFill>
+                <a:latin typeface="Arial"/>
+              </a:defRPr>
+            </a:pPr>
+            <a:r>
+              <a:t>•  Can operate on secure tactical intranet networks for defense logistics corridors.</a:t>
+            </a:r>
+          </a:p>
+        </p:txBody>
+      </p:sp>
+      <p:sp>
+        <p:nvSpPr>
+          <p:cNvPr id="7" name="Rounded Rectangle 6"/>
+          <p:cNvSpPr/>
+          <p:nvPr/>
+        </p:nvSpPr>
+        <p:spPr>
+          <a:xfrm>
+            <a:off x="7955280" y="1463040"/>
+            <a:ext cx="3383280" cy="4663440"/>
+          </a:xfrm>
+          <a:prstGeom prst="roundRect">
+            <a:avLst/>
+          </a:prstGeom>
+          <a:solidFill>
+            <a:srgbClr val="F0F4F8"/>
+          </a:solidFill>
+          <a:ln w="15240">
+            <a:solidFill>
+              <a:srgbClr val="CFD8DC"/>
+            </a:solidFill>
+          </a:ln>
+        </p:spPr>
+        <p:style>
+          <a:lnRef idx="1">
+            <a:schemeClr val="accent1"/>
+          </a:lnRef>
+          <a:fillRef idx="3">
+            <a:schemeClr val="accent1"/>
+          </a:fillRef>
+          <a:effectRef idx="2">
+            <a:schemeClr val="accent1"/>
+          </a:effectRef>
+          <a:fontRef idx="minor">
+            <a:schemeClr val="lt1"/>
+          </a:fontRef>
+        </p:style>
+        <p:txBody>
+          <a:bodyPr rtlCol="0" anchor="ctr"/>
+          <a:lstStyle/>
+          <a:p>
+            <a:pPr algn="ctr"/>
+          </a:p>
+        </p:txBody>
+      </p:sp>
+      <p:sp>
+        <p:nvSpPr>
+          <p:cNvPr id="8" name="TextBox 7"/>
+          <p:cNvSpPr txBox="1"/>
+          <p:nvPr/>
+        </p:nvSpPr>
+        <p:spPr>
+          <a:xfrm>
+            <a:off x="8119872" y="1600200"/>
+            <a:ext cx="3054096" cy="4389120"/>
+          </a:xfrm>
+          <a:prstGeom prst="rect">
+            <a:avLst/>
+          </a:prstGeom>
+          <a:noFill/>
+        </p:spPr>
+        <p:txBody>
+          <a:bodyPr wrap="square" lIns="0" tIns="0" rIns="0" bIns="0">
+            <a:spAutoFit/>
+          </a:bodyPr>
+          <a:lstStyle/>
+          <a:p>
+            <a:pPr>
+              <a:spcAft>
+                <a:spcPts val="200"/>
+              </a:spcAft>
+              <a:defRPr sz="1400" b="1">
+                <a:solidFill>
+                  <a:srgbClr val="123D6E"/>
+                </a:solidFill>
+                <a:latin typeface="Arial"/>
+              </a:defRPr>
+            </a:pPr>
+            <a:r>
+              <a:t>Multi-City Federation</a:t>
+            </a:r>
+          </a:p>
+          <a:p>
+            <a:pPr>
+              <a:spcAft>
+                <a:spcPts val="800"/>
+              </a:spcAft>
+              <a:defRPr sz="1000" b="1">
+                <a:solidFill>
+                  <a:srgbClr val="006DBD"/>
+                </a:solidFill>
+                <a:latin typeface="Arial"/>
+              </a:defRPr>
+            </a:pPr>
+            <a:r>
+              <a:t>Closed-Loop PWD SLA Governance</a:t>
+            </a:r>
+          </a:p>
+          <a:p>
+            <a:pPr>
+              <a:spcAft>
+                <a:spcPts val="400"/>
+              </a:spcAft>
+              <a:defRPr sz="950">
+                <a:solidFill>
+                  <a:srgbClr val="1C232A"/>
+                </a:solidFill>
+                <a:latin typeface="Arial"/>
+              </a:defRPr>
+            </a:pPr>
+            <a:r>
+              <a:t>•  Seamless multi-city switching: Chennai (GCC), Bengaluru (BBMP), Delhi (MCD).</a:t>
+            </a:r>
+          </a:p>
+          <a:p>
+            <a:pPr>
+              <a:spcAft>
+                <a:spcPts val="400"/>
+              </a:spcAft>
+              <a:defRPr sz="950">
+                <a:solidFill>
+                  <a:srgbClr val="1C232A"/>
+                </a:solidFill>
+                <a:latin typeface="Arial"/>
+              </a:defRPr>
+            </a:pPr>
+            <a:r>
+              <a:t>•  PostGIS ST_ClusterDBSCAN merges multi-bus passes with 15-meter consensus.</a:t>
+            </a:r>
+          </a:p>
+          <a:p>
+            <a:pPr>
+              <a:spcAft>
+                <a:spcPts val="400"/>
+              </a:spcAft>
+              <a:defRPr sz="950">
+                <a:solidFill>
+                  <a:srgbClr val="1C232A"/>
+                </a:solidFill>
+                <a:latin typeface="Arial"/>
+              </a:defRPr>
+            </a:pPr>
+            <a:r>
+              <a:t>•  Automated Repair Prioritization Index (RPI = 0.40S + 0.25D + 0.20R + 0.15P).</a:t>
+            </a:r>
+          </a:p>
+          <a:p>
+            <a:pPr>
+              <a:spcAft>
+                <a:spcPts val="400"/>
+              </a:spcAft>
+              <a:defRPr sz="950">
+                <a:solidFill>
+                  <a:srgbClr val="1C232A"/>
+                </a:solidFill>
+                <a:latin typeface="Arial"/>
+              </a:defRPr>
+            </a:pPr>
+            <a:r>
+              <a:t>•  Automatic contractor dispatch with IRC SP:20 repair budgeting &amp; 48h SLA countdowns.</a:t>
+            </a:r>
+          </a:p>
+          <a:p>
+            <a:pPr>
+              <a:spcAft>
+                <a:spcPts val="400"/>
+              </a:spcAft>
+              <a:defRPr sz="950">
+                <a:solidFill>
+                  <a:srgbClr val="1C232A"/>
+                </a:solidFill>
+                <a:latin typeface="Arial"/>
+              </a:defRPr>
+            </a:pPr>
+            <a:r>
+              <a:t>•  Generates Chief Engineer Monday Morning PDF Municipal Audits automatically.</a:t>
+            </a:r>
+          </a:p>
+        </p:txBody>
+      </p:sp>
+      <p:sp>
+        <p:nvSpPr>
+          <p:cNvPr id="9" name="TextBox 8"/>
+          <p:cNvSpPr txBox="1"/>
+          <p:nvPr/>
+        </p:nvSpPr>
+        <p:spPr>
+          <a:xfrm>
+            <a:off x="731520" y="6309360"/>
+            <a:ext cx="10698480" cy="365760"/>
+          </a:xfrm>
+          <a:prstGeom prst="rect">
+            <a:avLst/>
+          </a:prstGeom>
+          <a:noFill/>
+        </p:spPr>
+        <p:txBody>
+          <a:bodyPr wrap="none">
+            <a:spAutoFit/>
+          </a:bodyPr>
+          <a:lstStyle/>
+          <a:p>
+            <a:pPr>
+              <a:defRPr sz="850">
+                <a:solidFill>
+                  <a:srgbClr val="5A6B7C"/>
+                </a:solidFill>
+                <a:latin typeface="Arial"/>
+              </a:defRPr>
+            </a:pPr>
+            <a:r>
+              <a:t>VIGILANCE  •  SMART INDIA HACKATHON 2026 GRAND FINALE  •  BEL PROBLEM STATEMENT SIH26124</a:t>
+            </a:r>
+          </a:p>
+        </p:txBody>
+      </p:sp>
+    </p:spTree>
   </p:cSld>
   <p:clrMapOvr>
     <a:masterClrMapping/>

</xml_diff>